<commit_message>
Update deck: classic cover, client's outline plane, blue section 2 trail
Co-Authored-By: Claude Opus 5.5 <noreply@anthropic.com>
Claude-Session: https://claude.ai/code/session_013jPvFVKNtfNrx98C7yQEsV
</commit_message>
<xml_diff>
--- a/deliverables/InboxAlly_Sales_Call_Deck.pptx
+++ b/deliverables/InboxAlly_Sales_Call_Deck.pptx
@@ -118,7 +118,7 @@
   <p:extLst>
     <p:ext uri="{521415D9-36F7-43E2-AB2F-B90AF26B5E84}">
       <p14:sectionLst xmlns:p14="http://schemas.microsoft.com/office/powerpoint/2010/main">
-        <p14:section name="Sales call" id="{c496a26f-4c56-ac50-8956-6f3984bdf01a}">
+        <p14:section name="Sales call" id="{aea5b775-273e-ced6-67f2-7e88f7809fc3}">
           <p14:sldIdLst>
             <p14:sldId id="256"/>
             <p14:sldId id="257"/>
@@ -126,7 +126,7 @@
             <p14:sldId id="259"/>
           </p14:sldIdLst>
         </p14:section>
-        <p14:section name="Template layouts" id="{a2559ef9-929f-0358-4aed-04c349bba4f9}">
+        <p14:section name="Template layouts" id="{04e9aab8-843c-7b17-73f6-932a3ebb7d4e}">
           <p14:sldIdLst>
             <p14:sldId id="260"/>
             <p14:sldId id="261"/>
@@ -136,7 +136,7 @@
             <p14:sldId id="265"/>
           </p14:sldIdLst>
         </p14:section>
-        <p14:section name="Close" id="{e5e4e2f1-dd2c-2453-7eee-109c26b17320}">
+        <p14:section name="Close" id="{9f83ba1e-f66e-5786-95ce-3a68cd8378f1}">
           <p14:sldIdLst>
             <p14:sldId id="266"/>
             <p14:sldId id="267"/>
@@ -3496,7 +3496,7 @@
         </p:blipFill>
         <p:spPr>
           <a:xfrm>
-            <a:off x="812800" y="812800"/>
+            <a:off x="812800" y="711200"/>
             <a:ext cx="2844800" cy="590550"/>
           </a:xfrm>
           <a:prstGeom prst="rect">
@@ -3504,9 +3504,244 @@
           </a:prstGeom>
         </p:spPr>
       </p:pic>
+      <p:sp>
+        <p:nvSpPr>
+          <p:cNvPr id="3" name="Text 1"/>
+          <p:cNvSpPr txBox="1"/>
+          <p:nvPr/>
+        </p:nvSpPr>
+        <p:spPr>
+          <a:xfrm>
+            <a:off x="7569200" y="787400"/>
+            <a:ext cx="3810000" cy="215900"/>
+          </a:xfrm>
+          <a:prstGeom prst="rect">
+            <a:avLst/>
+          </a:prstGeom>
+          <a:noFill/>
+          <a:ln/>
+        </p:spPr>
+        <p:txBody>
+          <a:bodyPr wrap="square" lIns="0" tIns="0" rIns="0" bIns="0" rtlCol="0" anchor="t"/>
+          <a:lstStyle/>
+          <a:p>
+            <a:pPr algn="r" indent="0" marL="0">
+              <a:lnSpc>
+                <a:spcPct val="115000"/>
+              </a:lnSpc>
+              <a:buNone/>
+            </a:pPr>
+            <a:r>
+              <a:rPr lang="en-US" sz="1200" b="1" spc="100" kern="0" dirty="0">
+                <a:solidFill>
+                  <a:srgbClr val="0063FF"/>
+                </a:solidFill>
+                <a:latin typeface="Arial" pitchFamily="34" charset="0"/>
+                <a:ea typeface="Arial" pitchFamily="34" charset="-122"/>
+                <a:cs typeface="Arial" pitchFamily="34" charset="-120"/>
+              </a:rPr>
+              <a:t>DELIVERABILITY STRATEGY CALL</a:t>
+            </a:r>
+            <a:endParaRPr lang="en-US" sz="1200" dirty="0"/>
+          </a:p>
+        </p:txBody>
+      </p:sp>
+      <p:sp>
+        <p:nvSpPr>
+          <p:cNvPr id="4" name="Text 2"/>
+          <p:cNvSpPr txBox="1"/>
+          <p:nvPr/>
+        </p:nvSpPr>
+        <p:spPr>
+          <a:xfrm>
+            <a:off x="7569200" y="1028700"/>
+            <a:ext cx="3810000" cy="254000"/>
+          </a:xfrm>
+          <a:prstGeom prst="rect">
+            <a:avLst/>
+          </a:prstGeom>
+          <a:noFill/>
+          <a:ln/>
+        </p:spPr>
+        <p:txBody>
+          <a:bodyPr wrap="square" lIns="0" tIns="0" rIns="0" bIns="0" rtlCol="0" anchor="t"/>
+          <a:lstStyle/>
+          <a:p>
+            <a:pPr algn="r" indent="0" marL="0">
+              <a:lnSpc>
+                <a:spcPct val="115000"/>
+              </a:lnSpc>
+              <a:buNone/>
+            </a:pPr>
+            <a:r>
+              <a:rPr lang="en-US" sz="1400" dirty="0">
+                <a:solidFill>
+                  <a:srgbClr val="3D4451"/>
+                </a:solidFill>
+                <a:latin typeface="Arial" pitchFamily="34" charset="0"/>
+                <a:ea typeface="Arial" pitchFamily="34" charset="-122"/>
+                <a:cs typeface="Arial" pitchFamily="34" charset="-120"/>
+              </a:rPr>
+              <a:t>[Date]</a:t>
+            </a:r>
+            <a:endParaRPr lang="en-US" sz="1400" dirty="0"/>
+          </a:p>
+        </p:txBody>
+      </p:sp>
+      <p:sp>
+        <p:nvSpPr>
+          <p:cNvPr id="5" name="Text 3"/>
+          <p:cNvSpPr txBox="1"/>
+          <p:nvPr/>
+        </p:nvSpPr>
+        <p:spPr>
+          <a:xfrm>
+            <a:off x="812800" y="2260600"/>
+            <a:ext cx="5080000" cy="215900"/>
+          </a:xfrm>
+          <a:prstGeom prst="rect">
+            <a:avLst/>
+          </a:prstGeom>
+          <a:noFill/>
+          <a:ln/>
+        </p:spPr>
+        <p:txBody>
+          <a:bodyPr wrap="square" lIns="0" tIns="0" rIns="0" bIns="0" rtlCol="0" anchor="t"/>
+          <a:lstStyle/>
+          <a:p>
+            <a:pPr algn="l" indent="0" marL="0">
+              <a:lnSpc>
+                <a:spcPct val="115000"/>
+              </a:lnSpc>
+              <a:buNone/>
+            </a:pPr>
+            <a:r>
+              <a:rPr lang="en-US" sz="1200" b="1" spc="100" kern="0" dirty="0">
+                <a:solidFill>
+                  <a:srgbClr val="0063FF"/>
+                </a:solidFill>
+                <a:latin typeface="Arial" pitchFamily="34" charset="0"/>
+                <a:ea typeface="Arial" pitchFamily="34" charset="-122"/>
+                <a:cs typeface="Arial" pitchFamily="34" charset="-120"/>
+              </a:rPr>
+              <a:t>PREPARED FOR</a:t>
+            </a:r>
+            <a:endParaRPr lang="en-US" sz="1200" dirty="0"/>
+          </a:p>
+        </p:txBody>
+      </p:sp>
+      <p:sp>
+        <p:nvSpPr>
+          <p:cNvPr id="6" name="Client name"/>
+          <p:cNvSpPr txBox="1"/>
+          <p:nvPr/>
+        </p:nvSpPr>
+        <p:spPr>
+          <a:xfrm>
+            <a:off x="812800" y="2501900"/>
+            <a:ext cx="6350000" cy="952500"/>
+          </a:xfrm>
+          <a:prstGeom prst="rect">
+            <a:avLst/>
+          </a:prstGeom>
+          <a:noFill/>
+          <a:ln/>
+        </p:spPr>
+        <p:txBody>
+          <a:bodyPr wrap="square" lIns="0" tIns="0" rIns="0" bIns="0" rtlCol="0" anchor="t"/>
+          <a:lstStyle/>
+          <a:p>
+            <a:pPr algn="l" indent="0" marL="0">
+              <a:lnSpc>
+                <a:spcPct val="95000"/>
+              </a:lnSpc>
+              <a:buNone/>
+            </a:pPr>
+            <a:r>
+              <a:rPr lang="en-US" sz="6800" dirty="0">
+                <a:solidFill>
+                  <a:srgbClr val="2A2A2A"/>
+                </a:solidFill>
+                <a:latin typeface="Georgia" pitchFamily="34" charset="0"/>
+                <a:ea typeface="Georgia" pitchFamily="34" charset="-122"/>
+                <a:cs typeface="Georgia" pitchFamily="34" charset="-120"/>
+              </a:rPr>
+              <a:t>[Client name]</a:t>
+            </a:r>
+            <a:endParaRPr lang="en-US" sz="6800" dirty="0"/>
+          </a:p>
+        </p:txBody>
+      </p:sp>
+      <p:sp>
+        <p:nvSpPr>
+          <p:cNvPr id="7" name="Text 4"/>
+          <p:cNvSpPr txBox="1"/>
+          <p:nvPr/>
+        </p:nvSpPr>
+        <p:spPr>
+          <a:xfrm>
+            <a:off x="812800" y="3556000"/>
+            <a:ext cx="8255000" cy="406400"/>
+          </a:xfrm>
+          <a:prstGeom prst="rect">
+            <a:avLst/>
+          </a:prstGeom>
+          <a:noFill/>
+          <a:ln/>
+        </p:spPr>
+        <p:txBody>
+          <a:bodyPr wrap="square" lIns="0" tIns="0" rIns="0" bIns="0" rtlCol="0" anchor="t"/>
+          <a:lstStyle/>
+          <a:p>
+            <a:pPr algn="l" indent="0" marL="0">
+              <a:lnSpc>
+                <a:spcPct val="115000"/>
+              </a:lnSpc>
+              <a:buNone/>
+            </a:pPr>
+            <a:r>
+              <a:rPr lang="en-US" sz="2400" dirty="0">
+                <a:solidFill>
+                  <a:srgbClr val="0063FF"/>
+                </a:solidFill>
+                <a:latin typeface="Georgia" pitchFamily="34" charset="0"/>
+                <a:ea typeface="Georgia" pitchFamily="34" charset="-122"/>
+                <a:cs typeface="Georgia" pitchFamily="34" charset="-120"/>
+              </a:rPr>
+              <a:t>Better inbox results. Zero platform changes.</a:t>
+            </a:r>
+            <a:endParaRPr lang="en-US" sz="2400" dirty="0"/>
+          </a:p>
+        </p:txBody>
+      </p:sp>
+      <p:sp>
+        <p:nvSpPr>
+          <p:cNvPr id="8" name="Shape 5"/>
+          <p:cNvSpPr/>
+          <p:nvPr/>
+        </p:nvSpPr>
+        <p:spPr>
+          <a:xfrm>
+            <a:off x="812800" y="5410200"/>
+            <a:ext cx="4699000" cy="12700"/>
+          </a:xfrm>
+          <a:prstGeom prst="rect">
+            <a:avLst/>
+          </a:prstGeom>
+          <a:solidFill>
+            <a:srgbClr val="90BDFE"/>
+          </a:solidFill>
+          <a:ln w="12700">
+            <a:solidFill>
+              <a:srgbClr val="90BDFE"/>
+            </a:solidFill>
+            <a:prstDash val="solid"/>
+          </a:ln>
+        </p:spPr>
+      </p:sp>
       <p:pic>
         <p:nvPicPr>
-          <p:cNvPr id="3" name="Darren Blumenfeld" descr="Darren Blumenfeld">    </p:cNvPr>
+          <p:cNvPr id="9" name="Darren Blumenfeld" descr="Darren Blumenfeld">    </p:cNvPr>
           <p:cNvPicPr>
             <a:picLocks noChangeAspect="1"/>
           </p:cNvPicPr>
@@ -3520,8 +3755,8 @@
         </p:blipFill>
         <p:spPr>
           <a:xfrm>
-            <a:off x="5892800" y="812800"/>
-            <a:ext cx="584200" cy="584200"/>
+            <a:off x="812800" y="5638800"/>
+            <a:ext cx="508000" cy="508000"/>
           </a:xfrm>
           <a:prstGeom prst="ellipse">
             <a:avLst/>
@@ -3530,14 +3765,14 @@
       </p:pic>
       <p:sp>
         <p:nvSpPr>
-          <p:cNvPr id="4" name="Text 1"/>
-          <p:cNvSpPr txBox="1"/>
-          <p:nvPr/>
-        </p:nvSpPr>
-        <p:spPr>
-          <a:xfrm>
-            <a:off x="6604000" y="850900"/>
-            <a:ext cx="2095500" cy="254000"/>
+          <p:cNvPr id="10" name="Text 5"/>
+          <p:cNvSpPr txBox="1"/>
+          <p:nvPr/>
+        </p:nvSpPr>
+        <p:spPr>
+          <a:xfrm>
+            <a:off x="1447800" y="5664200"/>
+            <a:ext cx="1905000" cy="254000"/>
           </a:xfrm>
           <a:prstGeom prst="rect">
             <a:avLst/>
@@ -3556,7 +3791,7 @@
               <a:buNone/>
             </a:pPr>
             <a:r>
-              <a:rPr lang="en-US" sz="1500" b="1" dirty="0">
+              <a:rPr lang="en-US" sz="1400" b="1" dirty="0">
                 <a:solidFill>
                   <a:srgbClr val="2A2A2A"/>
                 </a:solidFill>
@@ -3566,20 +3801,20 @@
               </a:rPr>
               <a:t>Darren Blumenfeld</a:t>
             </a:r>
-            <a:endParaRPr lang="en-US" sz="1500" dirty="0"/>
-          </a:p>
-        </p:txBody>
-      </p:sp>
-      <p:sp>
-        <p:nvSpPr>
-          <p:cNvPr id="5" name="Text 2"/>
-          <p:cNvSpPr txBox="1"/>
-          <p:nvPr/>
-        </p:nvSpPr>
-        <p:spPr>
-          <a:xfrm>
-            <a:off x="6604000" y="1117600"/>
-            <a:ext cx="2095500" cy="228600"/>
+            <a:endParaRPr lang="en-US" sz="1400" dirty="0"/>
+          </a:p>
+        </p:txBody>
+      </p:sp>
+      <p:sp>
+        <p:nvSpPr>
+          <p:cNvPr id="11" name="Text 6"/>
+          <p:cNvSpPr txBox="1"/>
+          <p:nvPr/>
+        </p:nvSpPr>
+        <p:spPr>
+          <a:xfrm>
+            <a:off x="1447800" y="5905500"/>
+            <a:ext cx="1905000" cy="215900"/>
           </a:xfrm>
           <a:prstGeom prst="rect">
             <a:avLst/>
@@ -3598,7 +3833,7 @@
               <a:buNone/>
             </a:pPr>
             <a:r>
-              <a:rPr lang="en-US" sz="1300" dirty="0">
+              <a:rPr lang="en-US" sz="1200" dirty="0">
                 <a:solidFill>
                   <a:srgbClr val="0063FF"/>
                 </a:solidFill>
@@ -3608,13 +3843,13 @@
               </a:rPr>
               <a:t>Founder &amp; CEO</a:t>
             </a:r>
-            <a:endParaRPr lang="en-US" sz="1300" dirty="0"/>
+            <a:endParaRPr lang="en-US" sz="1200" dirty="0"/>
           </a:p>
         </p:txBody>
       </p:sp>
       <p:pic>
         <p:nvPicPr>
-          <p:cNvPr id="6" name="Matt Rice" descr="Matt Rice">    </p:cNvPr>
+          <p:cNvPr id="12" name="Matt Rice" descr="Matt Rice">    </p:cNvPr>
           <p:cNvPicPr>
             <a:picLocks noChangeAspect="1"/>
           </p:cNvPicPr>
@@ -3628,8 +3863,8 @@
         </p:blipFill>
         <p:spPr>
           <a:xfrm>
-            <a:off x="8737600" y="812800"/>
-            <a:ext cx="584200" cy="584200"/>
+            <a:off x="3302000" y="5638800"/>
+            <a:ext cx="508000" cy="508000"/>
           </a:xfrm>
           <a:prstGeom prst="ellipse">
             <a:avLst/>
@@ -3638,14 +3873,14 @@
       </p:pic>
       <p:sp>
         <p:nvSpPr>
-          <p:cNvPr id="7" name="Text 3"/>
-          <p:cNvSpPr txBox="1"/>
-          <p:nvPr/>
-        </p:nvSpPr>
-        <p:spPr>
-          <a:xfrm>
-            <a:off x="9448800" y="850900"/>
-            <a:ext cx="2413000" cy="254000"/>
+          <p:cNvPr id="13" name="Text 7"/>
+          <p:cNvSpPr txBox="1"/>
+          <p:nvPr/>
+        </p:nvSpPr>
+        <p:spPr>
+          <a:xfrm>
+            <a:off x="3937000" y="5664200"/>
+            <a:ext cx="2159000" cy="254000"/>
           </a:xfrm>
           <a:prstGeom prst="rect">
             <a:avLst/>
@@ -3664,7 +3899,7 @@
               <a:buNone/>
             </a:pPr>
             <a:r>
-              <a:rPr lang="en-US" sz="1500" b="1" dirty="0">
+              <a:rPr lang="en-US" sz="1400" b="1" dirty="0">
                 <a:solidFill>
                   <a:srgbClr val="2A2A2A"/>
                 </a:solidFill>
@@ -3674,20 +3909,20 @@
               </a:rPr>
               <a:t>Matt Rice</a:t>
             </a:r>
-            <a:endParaRPr lang="en-US" sz="1500" dirty="0"/>
-          </a:p>
-        </p:txBody>
-      </p:sp>
-      <p:sp>
-        <p:nvSpPr>
-          <p:cNvPr id="8" name="Text 4"/>
-          <p:cNvSpPr txBox="1"/>
-          <p:nvPr/>
-        </p:nvSpPr>
-        <p:spPr>
-          <a:xfrm>
-            <a:off x="9448800" y="1117600"/>
-            <a:ext cx="2540000" cy="228600"/>
+            <a:endParaRPr lang="en-US" sz="1400" dirty="0"/>
+          </a:p>
+        </p:txBody>
+      </p:sp>
+      <p:sp>
+        <p:nvSpPr>
+          <p:cNvPr id="14" name="Text 8"/>
+          <p:cNvSpPr txBox="1"/>
+          <p:nvPr/>
+        </p:nvSpPr>
+        <p:spPr>
+          <a:xfrm>
+            <a:off x="3937000" y="5905500"/>
+            <a:ext cx="2413000" cy="215900"/>
           </a:xfrm>
           <a:prstGeom prst="rect">
             <a:avLst/>
@@ -3706,7 +3941,7 @@
               <a:buNone/>
             </a:pPr>
             <a:r>
-              <a:rPr lang="en-US" sz="1300" dirty="0">
+              <a:rPr lang="en-US" sz="1200" dirty="0">
                 <a:solidFill>
                   <a:srgbClr val="0063FF"/>
                 </a:solidFill>
@@ -3716,175 +3951,7 @@
               </a:rPr>
               <a:t>Senior Deliverability Coach</a:t>
             </a:r>
-            <a:endParaRPr lang="en-US" sz="1300" dirty="0"/>
-          </a:p>
-        </p:txBody>
-      </p:sp>
-      <p:sp>
-        <p:nvSpPr>
-          <p:cNvPr id="9" name="Text 5"/>
-          <p:cNvSpPr txBox="1"/>
-          <p:nvPr/>
-        </p:nvSpPr>
-        <p:spPr>
-          <a:xfrm>
-            <a:off x="812800" y="1905000"/>
-            <a:ext cx="5080000" cy="215900"/>
-          </a:xfrm>
-          <a:prstGeom prst="rect">
-            <a:avLst/>
-          </a:prstGeom>
-          <a:noFill/>
-          <a:ln/>
-        </p:spPr>
-        <p:txBody>
-          <a:bodyPr wrap="square" lIns="0" tIns="0" rIns="0" bIns="0" rtlCol="0" anchor="t"/>
-          <a:lstStyle/>
-          <a:p>
-            <a:pPr algn="l" indent="0" marL="0">
-              <a:lnSpc>
-                <a:spcPct val="115000"/>
-              </a:lnSpc>
-              <a:buNone/>
-            </a:pPr>
-            <a:r>
-              <a:rPr lang="en-US" sz="1200" b="1" spc="100" kern="0" dirty="0">
-                <a:solidFill>
-                  <a:srgbClr val="0063FF"/>
-                </a:solidFill>
-                <a:latin typeface="Arial" pitchFamily="34" charset="0"/>
-                <a:ea typeface="Arial" pitchFamily="34" charset="-122"/>
-                <a:cs typeface="Arial" pitchFamily="34" charset="-120"/>
-              </a:rPr>
-              <a:t>PREPARED FOR</a:t>
-            </a:r>
             <a:endParaRPr lang="en-US" sz="1200" dirty="0"/>
-          </a:p>
-        </p:txBody>
-      </p:sp>
-      <p:sp>
-        <p:nvSpPr>
-          <p:cNvPr id="10" name="Client name"/>
-          <p:cNvSpPr txBox="1"/>
-          <p:nvPr/>
-        </p:nvSpPr>
-        <p:spPr>
-          <a:xfrm>
-            <a:off x="812800" y="2133600"/>
-            <a:ext cx="9525000" cy="889000"/>
-          </a:xfrm>
-          <a:prstGeom prst="rect">
-            <a:avLst/>
-          </a:prstGeom>
-          <a:noFill/>
-          <a:ln/>
-        </p:spPr>
-        <p:txBody>
-          <a:bodyPr wrap="square" lIns="0" tIns="0" rIns="0" bIns="0" rtlCol="0" anchor="t"/>
-          <a:lstStyle/>
-          <a:p>
-            <a:pPr algn="l" indent="0" marL="0">
-              <a:lnSpc>
-                <a:spcPct val="95000"/>
-              </a:lnSpc>
-              <a:buNone/>
-            </a:pPr>
-            <a:r>
-              <a:rPr lang="en-US" sz="6000" dirty="0">
-                <a:solidFill>
-                  <a:srgbClr val="2A2A2A"/>
-                </a:solidFill>
-                <a:latin typeface="Georgia" pitchFamily="34" charset="0"/>
-                <a:ea typeface="Georgia" pitchFamily="34" charset="-122"/>
-                <a:cs typeface="Georgia" pitchFamily="34" charset="-120"/>
-              </a:rPr>
-              <a:t>[Client name]</a:t>
-            </a:r>
-            <a:endParaRPr lang="en-US" sz="6000" dirty="0"/>
-          </a:p>
-        </p:txBody>
-      </p:sp>
-      <p:sp>
-        <p:nvSpPr>
-          <p:cNvPr id="11" name="Text 6"/>
-          <p:cNvSpPr txBox="1"/>
-          <p:nvPr/>
-        </p:nvSpPr>
-        <p:spPr>
-          <a:xfrm>
-            <a:off x="812800" y="3098800"/>
-            <a:ext cx="9525000" cy="381000"/>
-          </a:xfrm>
-          <a:prstGeom prst="rect">
-            <a:avLst/>
-          </a:prstGeom>
-          <a:noFill/>
-          <a:ln/>
-        </p:spPr>
-        <p:txBody>
-          <a:bodyPr wrap="square" lIns="0" tIns="0" rIns="0" bIns="0" rtlCol="0" anchor="t"/>
-          <a:lstStyle/>
-          <a:p>
-            <a:pPr algn="l" indent="0" marL="0">
-              <a:lnSpc>
-                <a:spcPct val="115000"/>
-              </a:lnSpc>
-              <a:buNone/>
-            </a:pPr>
-            <a:r>
-              <a:rPr lang="en-US" sz="2200" dirty="0">
-                <a:solidFill>
-                  <a:srgbClr val="0063FF"/>
-                </a:solidFill>
-                <a:latin typeface="Georgia" pitchFamily="34" charset="0"/>
-                <a:ea typeface="Georgia" pitchFamily="34" charset="-122"/>
-                <a:cs typeface="Georgia" pitchFamily="34" charset="-120"/>
-              </a:rPr>
-              <a:t>Better inbox results. Zero platform changes.</a:t>
-            </a:r>
-            <a:endParaRPr lang="en-US" sz="2200" dirty="0"/>
-          </a:p>
-        </p:txBody>
-      </p:sp>
-      <p:sp>
-        <p:nvSpPr>
-          <p:cNvPr id="12" name="Text 7"/>
-          <p:cNvSpPr txBox="1"/>
-          <p:nvPr/>
-        </p:nvSpPr>
-        <p:spPr>
-          <a:xfrm>
-            <a:off x="812800" y="3568700"/>
-            <a:ext cx="7620000" cy="254000"/>
-          </a:xfrm>
-          <a:prstGeom prst="rect">
-            <a:avLst/>
-          </a:prstGeom>
-          <a:noFill/>
-          <a:ln/>
-        </p:spPr>
-        <p:txBody>
-          <a:bodyPr wrap="square" lIns="0" tIns="0" rIns="0" bIns="0" rtlCol="0" anchor="t"/>
-          <a:lstStyle/>
-          <a:p>
-            <a:pPr algn="l" indent="0" marL="0">
-              <a:lnSpc>
-                <a:spcPct val="115000"/>
-              </a:lnSpc>
-              <a:buNone/>
-            </a:pPr>
-            <a:r>
-              <a:rPr lang="en-US" sz="1400" dirty="0">
-                <a:solidFill>
-                  <a:srgbClr val="2A2A2A"/>
-                </a:solidFill>
-                <a:latin typeface="Arial" pitchFamily="34" charset="0"/>
-                <a:ea typeface="Arial" pitchFamily="34" charset="-122"/>
-                <a:cs typeface="Arial" pitchFamily="34" charset="-120"/>
-              </a:rPr>
-              <a:t>Deliverability strategy call · [Date]</a:t>
-            </a:r>
-            <a:endParaRPr lang="en-US" sz="1400" dirty="0"/>
           </a:p>
         </p:txBody>
       </p:sp>
@@ -4040,7 +4107,7 @@
       </p:sp>
       <p:sp>
         <p:nvSpPr>
-          <p:cNvPr id="5" name="Text 79"/>
+          <p:cNvPr id="5" name="Text 80"/>
           <p:cNvSpPr txBox="1"/>
           <p:nvPr/>
         </p:nvSpPr>
@@ -4082,7 +4149,7 @@
       </p:sp>
       <p:sp>
         <p:nvSpPr>
-          <p:cNvPr id="6" name="Text 80"/>
+          <p:cNvPr id="6" name="Text 81"/>
           <p:cNvSpPr txBox="1"/>
           <p:nvPr/>
         </p:nvSpPr>
@@ -4189,7 +4256,7 @@
       </p:sp>
       <p:sp>
         <p:nvSpPr>
-          <p:cNvPr id="9" name="Text 81"/>
+          <p:cNvPr id="9" name="Text 82"/>
           <p:cNvSpPr txBox="1"/>
           <p:nvPr/>
         </p:nvSpPr>
@@ -4231,7 +4298,7 @@
       </p:sp>
       <p:sp>
         <p:nvSpPr>
-          <p:cNvPr id="10" name="Text 82"/>
+          <p:cNvPr id="10" name="Text 83"/>
           <p:cNvSpPr txBox="1"/>
           <p:nvPr/>
         </p:nvSpPr>
@@ -4338,7 +4405,7 @@
       </p:sp>
       <p:sp>
         <p:nvSpPr>
-          <p:cNvPr id="13" name="Text 83"/>
+          <p:cNvPr id="13" name="Text 84"/>
           <p:cNvSpPr txBox="1"/>
           <p:nvPr/>
         </p:nvSpPr>
@@ -4380,7 +4447,7 @@
       </p:sp>
       <p:sp>
         <p:nvSpPr>
-          <p:cNvPr id="14" name="Text 84"/>
+          <p:cNvPr id="14" name="Text 85"/>
           <p:cNvSpPr txBox="1"/>
           <p:nvPr/>
         </p:nvSpPr>
@@ -4487,7 +4554,7 @@
       </p:sp>
       <p:sp>
         <p:nvSpPr>
-          <p:cNvPr id="17" name="Text 85"/>
+          <p:cNvPr id="17" name="Text 86"/>
           <p:cNvSpPr txBox="1"/>
           <p:nvPr/>
         </p:nvSpPr>
@@ -4529,7 +4596,7 @@
       </p:sp>
       <p:sp>
         <p:nvSpPr>
-          <p:cNvPr id="18" name="Text 86"/>
+          <p:cNvPr id="18" name="Text 87"/>
           <p:cNvSpPr txBox="1"/>
           <p:nvPr/>
         </p:nvSpPr>
@@ -4571,7 +4638,7 @@
       </p:sp>
       <p:sp>
         <p:nvSpPr>
-          <p:cNvPr id="19" name="Text 87"/>
+          <p:cNvPr id="19" name="Text 88"/>
           <p:cNvSpPr txBox="1"/>
           <p:nvPr/>
         </p:nvSpPr>
@@ -4710,7 +4777,7 @@
       </p:pic>
       <p:sp>
         <p:nvSpPr>
-          <p:cNvPr id="3" name="Text 88"/>
+          <p:cNvPr id="3" name="Text 89"/>
           <p:cNvSpPr txBox="1"/>
           <p:nvPr/>
         </p:nvSpPr>
@@ -4752,7 +4819,7 @@
       </p:sp>
       <p:sp>
         <p:nvSpPr>
-          <p:cNvPr id="4" name="Text 89"/>
+          <p:cNvPr id="4" name="Text 90"/>
           <p:cNvSpPr txBox="1"/>
           <p:nvPr/>
         </p:nvSpPr>
@@ -4929,7 +4996,7 @@
       </p:sp>
       <p:sp>
         <p:nvSpPr>
-          <p:cNvPr id="5" name="Text 90"/>
+          <p:cNvPr id="5" name="Text 91"/>
           <p:cNvSpPr txBox="1"/>
           <p:nvPr/>
         </p:nvSpPr>
@@ -4971,7 +5038,7 @@
       </p:sp>
       <p:sp>
         <p:nvSpPr>
-          <p:cNvPr id="6" name="Text 91"/>
+          <p:cNvPr id="6" name="Text 92"/>
           <p:cNvSpPr txBox="1"/>
           <p:nvPr/>
         </p:nvSpPr>
@@ -5013,7 +5080,7 @@
       </p:sp>
       <p:sp>
         <p:nvSpPr>
-          <p:cNvPr id="7" name="Text 92"/>
+          <p:cNvPr id="7" name="Text 93"/>
           <p:cNvSpPr txBox="1"/>
           <p:nvPr/>
         </p:nvSpPr>
@@ -5082,7 +5149,7 @@
       </p:sp>
       <p:sp>
         <p:nvSpPr>
-          <p:cNvPr id="9" name="Text 93"/>
+          <p:cNvPr id="9" name="Text 94"/>
           <p:cNvSpPr txBox="1"/>
           <p:nvPr/>
         </p:nvSpPr>
@@ -5124,7 +5191,7 @@
       </p:sp>
       <p:sp>
         <p:nvSpPr>
-          <p:cNvPr id="10" name="Text 94"/>
+          <p:cNvPr id="10" name="Text 95"/>
           <p:cNvSpPr txBox="1"/>
           <p:nvPr/>
         </p:nvSpPr>
@@ -5166,7 +5233,7 @@
       </p:sp>
       <p:sp>
         <p:nvSpPr>
-          <p:cNvPr id="11" name="Text 95"/>
+          <p:cNvPr id="11" name="Text 96"/>
           <p:cNvSpPr txBox="1"/>
           <p:nvPr/>
         </p:nvSpPr>
@@ -5235,7 +5302,7 @@
       </p:sp>
       <p:sp>
         <p:nvSpPr>
-          <p:cNvPr id="13" name="Text 96"/>
+          <p:cNvPr id="13" name="Text 97"/>
           <p:cNvSpPr txBox="1"/>
           <p:nvPr/>
         </p:nvSpPr>
@@ -5277,7 +5344,7 @@
       </p:sp>
       <p:sp>
         <p:nvSpPr>
-          <p:cNvPr id="14" name="Text 97"/>
+          <p:cNvPr id="14" name="Text 98"/>
           <p:cNvSpPr txBox="1"/>
           <p:nvPr/>
         </p:nvSpPr>
@@ -5319,7 +5386,7 @@
       </p:sp>
       <p:sp>
         <p:nvSpPr>
-          <p:cNvPr id="15" name="Text 98"/>
+          <p:cNvPr id="15" name="Text 99"/>
           <p:cNvSpPr txBox="1"/>
           <p:nvPr/>
         </p:nvSpPr>
@@ -5388,7 +5455,7 @@
       </p:sp>
       <p:sp>
         <p:nvSpPr>
-          <p:cNvPr id="17" name="Text 99"/>
+          <p:cNvPr id="17" name="Text 100"/>
           <p:cNvSpPr txBox="1"/>
           <p:nvPr/>
         </p:nvSpPr>
@@ -5454,7 +5521,7 @@
       </p:pic>
       <p:sp>
         <p:nvSpPr>
-          <p:cNvPr id="19" name="Text 100"/>
+          <p:cNvPr id="19" name="Text 101"/>
           <p:cNvSpPr txBox="1"/>
           <p:nvPr/>
         </p:nvSpPr>
@@ -5496,7 +5563,7 @@
       </p:sp>
       <p:sp>
         <p:nvSpPr>
-          <p:cNvPr id="20" name="Text 101"/>
+          <p:cNvPr id="20" name="Text 102"/>
           <p:cNvSpPr txBox="1"/>
           <p:nvPr/>
         </p:nvSpPr>
@@ -5538,7 +5605,7 @@
       </p:sp>
       <p:sp>
         <p:nvSpPr>
-          <p:cNvPr id="21" name="Text 102"/>
+          <p:cNvPr id="21" name="Text 103"/>
           <p:cNvSpPr txBox="1"/>
           <p:nvPr/>
         </p:nvSpPr>
@@ -5627,7 +5694,7 @@
       </p:pic>
       <p:sp>
         <p:nvSpPr>
-          <p:cNvPr id="24" name="Text 103"/>
+          <p:cNvPr id="24" name="Text 104"/>
           <p:cNvSpPr txBox="1"/>
           <p:nvPr/>
         </p:nvSpPr>
@@ -5669,7 +5736,7 @@
       </p:sp>
       <p:sp>
         <p:nvSpPr>
-          <p:cNvPr id="25" name="Text 104"/>
+          <p:cNvPr id="25" name="Text 105"/>
           <p:cNvSpPr txBox="1"/>
           <p:nvPr/>
         </p:nvSpPr>
@@ -5711,7 +5778,7 @@
       </p:sp>
       <p:sp>
         <p:nvSpPr>
-          <p:cNvPr id="26" name="Text 105"/>
+          <p:cNvPr id="26" name="Text 106"/>
           <p:cNvSpPr txBox="1"/>
           <p:nvPr/>
         </p:nvSpPr>
@@ -6014,7 +6081,7 @@
       </p:sp>
       <p:sp>
         <p:nvSpPr>
-          <p:cNvPr id="8" name="Text 8"/>
+          <p:cNvPr id="8" name="Text 9"/>
           <p:cNvSpPr txBox="1"/>
           <p:nvPr/>
         </p:nvSpPr>
@@ -6056,7 +6123,7 @@
       </p:sp>
       <p:sp>
         <p:nvSpPr>
-          <p:cNvPr id="9" name="Text 9"/>
+          <p:cNvPr id="9" name="Text 10"/>
           <p:cNvSpPr txBox="1"/>
           <p:nvPr/>
         </p:nvSpPr>
@@ -6098,7 +6165,7 @@
       </p:sp>
       <p:sp>
         <p:nvSpPr>
-          <p:cNvPr id="10" name="Text 10"/>
+          <p:cNvPr id="10" name="Text 11"/>
           <p:cNvSpPr txBox="1"/>
           <p:nvPr/>
         </p:nvSpPr>
@@ -6140,7 +6207,7 @@
       </p:sp>
       <p:sp>
         <p:nvSpPr>
-          <p:cNvPr id="11" name="Text 11"/>
+          <p:cNvPr id="11" name="Text 12"/>
           <p:cNvSpPr txBox="1"/>
           <p:nvPr/>
         </p:nvSpPr>
@@ -6182,7 +6249,7 @@
       </p:sp>
       <p:sp>
         <p:nvSpPr>
-          <p:cNvPr id="12" name="Text 12"/>
+          <p:cNvPr id="12" name="Text 13"/>
           <p:cNvSpPr txBox="1"/>
           <p:nvPr/>
         </p:nvSpPr>
@@ -6224,7 +6291,7 @@
       </p:sp>
       <p:sp>
         <p:nvSpPr>
-          <p:cNvPr id="13" name="Text 13"/>
+          <p:cNvPr id="13" name="Text 14"/>
           <p:cNvSpPr txBox="1"/>
           <p:nvPr/>
         </p:nvSpPr>
@@ -6293,7 +6360,7 @@
       </p:sp>
       <p:sp>
         <p:nvSpPr>
-          <p:cNvPr id="15" name="Text 14"/>
+          <p:cNvPr id="15" name="Text 15"/>
           <p:cNvSpPr txBox="1"/>
           <p:nvPr/>
         </p:nvSpPr>
@@ -6335,7 +6402,7 @@
       </p:sp>
       <p:sp>
         <p:nvSpPr>
-          <p:cNvPr id="16" name="Text 15"/>
+          <p:cNvPr id="16" name="Text 16"/>
           <p:cNvSpPr txBox="1"/>
           <p:nvPr/>
         </p:nvSpPr>
@@ -6377,7 +6444,7 @@
       </p:sp>
       <p:sp>
         <p:nvSpPr>
-          <p:cNvPr id="17" name="Text 16"/>
+          <p:cNvPr id="17" name="Text 17"/>
           <p:cNvSpPr txBox="1"/>
           <p:nvPr/>
         </p:nvSpPr>
@@ -6582,7 +6649,7 @@
       </p:sp>
       <p:sp>
         <p:nvSpPr>
-          <p:cNvPr id="5" name="Text 17"/>
+          <p:cNvPr id="5" name="Text 18"/>
           <p:cNvSpPr txBox="1"/>
           <p:nvPr/>
         </p:nvSpPr>
@@ -6649,7 +6716,7 @@
       </p:sp>
       <p:sp>
         <p:nvSpPr>
-          <p:cNvPr id="7" name="Text 18"/>
+          <p:cNvPr id="7" name="Text 19"/>
           <p:cNvSpPr txBox="1"/>
           <p:nvPr/>
         </p:nvSpPr>
@@ -6716,7 +6783,7 @@
       </p:sp>
       <p:sp>
         <p:nvSpPr>
-          <p:cNvPr id="9" name="Text 19"/>
+          <p:cNvPr id="9" name="Text 20"/>
           <p:cNvSpPr txBox="1"/>
           <p:nvPr/>
         </p:nvSpPr>
@@ -6783,7 +6850,7 @@
       </p:sp>
       <p:sp>
         <p:nvSpPr>
-          <p:cNvPr id="11" name="Text 20"/>
+          <p:cNvPr id="11" name="Text 21"/>
           <p:cNvSpPr txBox="1"/>
           <p:nvPr/>
         </p:nvSpPr>
@@ -6850,7 +6917,7 @@
       </p:sp>
       <p:sp>
         <p:nvSpPr>
-          <p:cNvPr id="13" name="Text 21"/>
+          <p:cNvPr id="13" name="Text 22"/>
           <p:cNvSpPr txBox="1"/>
           <p:nvPr/>
         </p:nvSpPr>
@@ -6892,7 +6959,7 @@
       </p:sp>
       <p:sp>
         <p:nvSpPr>
-          <p:cNvPr id="14" name="Text 22"/>
+          <p:cNvPr id="14" name="Text 23"/>
           <p:cNvSpPr txBox="1"/>
           <p:nvPr/>
         </p:nvSpPr>
@@ -6934,7 +7001,7 @@
       </p:sp>
       <p:sp>
         <p:nvSpPr>
-          <p:cNvPr id="15" name="Text 23"/>
+          <p:cNvPr id="15" name="Text 24"/>
           <p:cNvSpPr txBox="1"/>
           <p:nvPr/>
         </p:nvSpPr>
@@ -6976,7 +7043,7 @@
       </p:sp>
       <p:sp>
         <p:nvSpPr>
-          <p:cNvPr id="16" name="Text 24"/>
+          <p:cNvPr id="16" name="Text 25"/>
           <p:cNvSpPr txBox="1"/>
           <p:nvPr/>
         </p:nvSpPr>
@@ -7018,7 +7085,7 @@
       </p:sp>
       <p:sp>
         <p:nvSpPr>
-          <p:cNvPr id="17" name="Text 25"/>
+          <p:cNvPr id="17" name="Text 26"/>
           <p:cNvSpPr txBox="1"/>
           <p:nvPr/>
         </p:nvSpPr>
@@ -7060,7 +7127,7 @@
       </p:sp>
       <p:sp>
         <p:nvSpPr>
-          <p:cNvPr id="18" name="Text 26"/>
+          <p:cNvPr id="18" name="Text 27"/>
           <p:cNvSpPr txBox="1"/>
           <p:nvPr/>
         </p:nvSpPr>
@@ -7102,7 +7169,7 @@
       </p:sp>
       <p:sp>
         <p:nvSpPr>
-          <p:cNvPr id="19" name="Text 27"/>
+          <p:cNvPr id="19" name="Text 28"/>
           <p:cNvSpPr txBox="1"/>
           <p:nvPr/>
         </p:nvSpPr>
@@ -7144,7 +7211,7 @@
       </p:sp>
       <p:sp>
         <p:nvSpPr>
-          <p:cNvPr id="20" name="Text 28"/>
+          <p:cNvPr id="20" name="Text 29"/>
           <p:cNvSpPr txBox="1"/>
           <p:nvPr/>
         </p:nvSpPr>
@@ -7186,7 +7253,7 @@
       </p:sp>
       <p:sp>
         <p:nvSpPr>
-          <p:cNvPr id="21" name="Text 29"/>
+          <p:cNvPr id="21" name="Text 30"/>
           <p:cNvSpPr txBox="1"/>
           <p:nvPr/>
         </p:nvSpPr>
@@ -7228,7 +7295,7 @@
       </p:sp>
       <p:sp>
         <p:nvSpPr>
-          <p:cNvPr id="22" name="Text 30"/>
+          <p:cNvPr id="22" name="Text 31"/>
           <p:cNvSpPr txBox="1"/>
           <p:nvPr/>
         </p:nvSpPr>
@@ -7270,7 +7337,7 @@
       </p:sp>
       <p:sp>
         <p:nvSpPr>
-          <p:cNvPr id="23" name="Text 31"/>
+          <p:cNvPr id="23" name="Text 32"/>
           <p:cNvSpPr txBox="1"/>
           <p:nvPr/>
         </p:nvSpPr>
@@ -7312,7 +7379,7 @@
       </p:sp>
       <p:sp>
         <p:nvSpPr>
-          <p:cNvPr id="24" name="Text 32"/>
+          <p:cNvPr id="24" name="Text 33"/>
           <p:cNvSpPr txBox="1"/>
           <p:nvPr/>
         </p:nvSpPr>
@@ -7354,7 +7421,7 @@
       </p:sp>
       <p:sp>
         <p:nvSpPr>
-          <p:cNvPr id="25" name="Text 33"/>
+          <p:cNvPr id="25" name="Text 34"/>
           <p:cNvSpPr txBox="1"/>
           <p:nvPr/>
         </p:nvSpPr>
@@ -7396,7 +7463,7 @@
       </p:sp>
       <p:sp>
         <p:nvSpPr>
-          <p:cNvPr id="26" name="Text 34"/>
+          <p:cNvPr id="26" name="Text 35"/>
           <p:cNvSpPr txBox="1"/>
           <p:nvPr/>
         </p:nvSpPr>
@@ -7438,7 +7505,7 @@
       </p:sp>
       <p:sp>
         <p:nvSpPr>
-          <p:cNvPr id="27" name="Text 35"/>
+          <p:cNvPr id="27" name="Text 36"/>
           <p:cNvSpPr txBox="1"/>
           <p:nvPr/>
         </p:nvSpPr>
@@ -7480,7 +7547,7 @@
       </p:sp>
       <p:sp>
         <p:nvSpPr>
-          <p:cNvPr id="28" name="Text 36"/>
+          <p:cNvPr id="28" name="Text 37"/>
           <p:cNvSpPr txBox="1"/>
           <p:nvPr/>
         </p:nvSpPr>
@@ -7549,7 +7616,7 @@
       </p:sp>
       <p:sp>
         <p:nvSpPr>
-          <p:cNvPr id="30" name="Text 37"/>
+          <p:cNvPr id="30" name="Text 38"/>
           <p:cNvSpPr txBox="1"/>
           <p:nvPr/>
         </p:nvSpPr>
@@ -7591,7 +7658,7 @@
       </p:sp>
       <p:sp>
         <p:nvSpPr>
-          <p:cNvPr id="31" name="Text 38"/>
+          <p:cNvPr id="31" name="Text 39"/>
           <p:cNvSpPr txBox="1"/>
           <p:nvPr/>
         </p:nvSpPr>
@@ -7656,7 +7723,7 @@
       </p:sp>
       <p:sp>
         <p:nvSpPr>
-          <p:cNvPr id="33" name="Text 39"/>
+          <p:cNvPr id="33" name="Text 40"/>
           <p:cNvSpPr txBox="1"/>
           <p:nvPr/>
         </p:nvSpPr>
@@ -7721,7 +7788,7 @@
       </p:sp>
       <p:sp>
         <p:nvSpPr>
-          <p:cNvPr id="35" name="Text 40"/>
+          <p:cNvPr id="35" name="Text 41"/>
           <p:cNvSpPr txBox="1"/>
           <p:nvPr/>
         </p:nvSpPr>
@@ -7786,7 +7853,7 @@
       </p:sp>
       <p:sp>
         <p:nvSpPr>
-          <p:cNvPr id="37" name="Text 41"/>
+          <p:cNvPr id="37" name="Text 42"/>
           <p:cNvSpPr txBox="1"/>
           <p:nvPr/>
         </p:nvSpPr>
@@ -8028,7 +8095,7 @@
       </p:sp>
       <p:sp>
         <p:nvSpPr>
-          <p:cNvPr id="4" name="Text 42"/>
+          <p:cNvPr id="4" name="Text 43"/>
           <p:cNvSpPr txBox="1"/>
           <p:nvPr/>
         </p:nvSpPr>
@@ -8070,7 +8137,7 @@
       </p:sp>
       <p:sp>
         <p:nvSpPr>
-          <p:cNvPr id="5" name="Text 43"/>
+          <p:cNvPr id="5" name="Text 44"/>
           <p:cNvSpPr txBox="1"/>
           <p:nvPr/>
         </p:nvSpPr>
@@ -8139,7 +8206,7 @@
       </p:sp>
       <p:sp>
         <p:nvSpPr>
-          <p:cNvPr id="7" name="Text 44"/>
+          <p:cNvPr id="7" name="Text 45"/>
           <p:cNvSpPr txBox="1"/>
           <p:nvPr/>
         </p:nvSpPr>
@@ -8181,7 +8248,7 @@
       </p:sp>
       <p:sp>
         <p:nvSpPr>
-          <p:cNvPr id="8" name="Text 45"/>
+          <p:cNvPr id="8" name="Text 46"/>
           <p:cNvSpPr txBox="1"/>
           <p:nvPr/>
         </p:nvSpPr>
@@ -8250,7 +8317,7 @@
       </p:sp>
       <p:sp>
         <p:nvSpPr>
-          <p:cNvPr id="10" name="Text 46"/>
+          <p:cNvPr id="10" name="Text 47"/>
           <p:cNvSpPr txBox="1"/>
           <p:nvPr/>
         </p:nvSpPr>
@@ -8292,7 +8359,7 @@
       </p:sp>
       <p:sp>
         <p:nvSpPr>
-          <p:cNvPr id="11" name="Text 47"/>
+          <p:cNvPr id="11" name="Text 48"/>
           <p:cNvSpPr txBox="1"/>
           <p:nvPr/>
         </p:nvSpPr>
@@ -8361,7 +8428,7 @@
       </p:sp>
       <p:sp>
         <p:nvSpPr>
-          <p:cNvPr id="13" name="Text 48"/>
+          <p:cNvPr id="13" name="Text 49"/>
           <p:cNvSpPr txBox="1"/>
           <p:nvPr/>
         </p:nvSpPr>
@@ -8403,7 +8470,7 @@
       </p:sp>
       <p:sp>
         <p:nvSpPr>
-          <p:cNvPr id="14" name="Text 49"/>
+          <p:cNvPr id="14" name="Text 50"/>
           <p:cNvSpPr txBox="1"/>
           <p:nvPr/>
         </p:nvSpPr>
@@ -8445,7 +8512,7 @@
       </p:sp>
       <p:sp>
         <p:nvSpPr>
-          <p:cNvPr id="15" name="Text 50"/>
+          <p:cNvPr id="15" name="Text 51"/>
           <p:cNvSpPr txBox="1"/>
           <p:nvPr/>
         </p:nvSpPr>
@@ -8487,7 +8554,7 @@
       </p:sp>
       <p:sp>
         <p:nvSpPr>
-          <p:cNvPr id="16" name="Text 51"/>
+          <p:cNvPr id="16" name="Text 52"/>
           <p:cNvSpPr txBox="1"/>
           <p:nvPr/>
         </p:nvSpPr>
@@ -8529,7 +8596,7 @@
       </p:sp>
       <p:sp>
         <p:nvSpPr>
-          <p:cNvPr id="17" name="Text 52"/>
+          <p:cNvPr id="17" name="Text 53"/>
           <p:cNvSpPr txBox="1"/>
           <p:nvPr/>
         </p:nvSpPr>
@@ -8571,7 +8638,7 @@
       </p:sp>
       <p:sp>
         <p:nvSpPr>
-          <p:cNvPr id="18" name="Text 53"/>
+          <p:cNvPr id="18" name="Text 54"/>
           <p:cNvSpPr txBox="1"/>
           <p:nvPr/>
         </p:nvSpPr>
@@ -8613,7 +8680,7 @@
       </p:sp>
       <p:sp>
         <p:nvSpPr>
-          <p:cNvPr id="19" name="Text 54"/>
+          <p:cNvPr id="19" name="Text 55"/>
           <p:cNvSpPr txBox="1"/>
           <p:nvPr/>
         </p:nvSpPr>
@@ -8655,7 +8722,7 @@
       </p:sp>
       <p:sp>
         <p:nvSpPr>
-          <p:cNvPr id="20" name="Text 55"/>
+          <p:cNvPr id="20" name="Text 56"/>
           <p:cNvSpPr txBox="1"/>
           <p:nvPr/>
         </p:nvSpPr>
@@ -8697,7 +8764,7 @@
       </p:sp>
       <p:sp>
         <p:nvSpPr>
-          <p:cNvPr id="21" name="Text 56"/>
+          <p:cNvPr id="21" name="Text 57"/>
           <p:cNvSpPr txBox="1"/>
           <p:nvPr/>
         </p:nvSpPr>
@@ -8739,7 +8806,7 @@
       </p:sp>
       <p:sp>
         <p:nvSpPr>
-          <p:cNvPr id="22" name="Text 57"/>
+          <p:cNvPr id="22" name="Text 58"/>
           <p:cNvSpPr txBox="1"/>
           <p:nvPr/>
         </p:nvSpPr>
@@ -8781,7 +8848,7 @@
       </p:sp>
       <p:sp>
         <p:nvSpPr>
-          <p:cNvPr id="23" name="Text 58"/>
+          <p:cNvPr id="23" name="Text 59"/>
           <p:cNvSpPr txBox="1"/>
           <p:nvPr/>
         </p:nvSpPr>
@@ -8823,7 +8890,7 @@
       </p:sp>
       <p:sp>
         <p:nvSpPr>
-          <p:cNvPr id="24" name="Text 59"/>
+          <p:cNvPr id="24" name="Text 60"/>
           <p:cNvSpPr txBox="1"/>
           <p:nvPr/>
         </p:nvSpPr>
@@ -9437,7 +9504,7 @@
       </p:sp>
       <p:sp>
         <p:nvSpPr>
-          <p:cNvPr id="4" name="Text 60"/>
+          <p:cNvPr id="4" name="Text 61"/>
           <p:cNvSpPr txBox="1"/>
           <p:nvPr/>
         </p:nvSpPr>
@@ -9479,7 +9546,7 @@
       </p:sp>
       <p:sp>
         <p:nvSpPr>
-          <p:cNvPr id="5" name="Text 61"/>
+          <p:cNvPr id="5" name="Text 62"/>
           <p:cNvSpPr txBox="1"/>
           <p:nvPr/>
         </p:nvSpPr>
@@ -9521,7 +9588,7 @@
       </p:sp>
       <p:sp>
         <p:nvSpPr>
-          <p:cNvPr id="6" name="Text 62"/>
+          <p:cNvPr id="6" name="Text 63"/>
           <p:cNvSpPr txBox="1"/>
           <p:nvPr/>
         </p:nvSpPr>
@@ -9563,7 +9630,7 @@
       </p:sp>
       <p:sp>
         <p:nvSpPr>
-          <p:cNvPr id="7" name="Text 63"/>
+          <p:cNvPr id="7" name="Text 64"/>
           <p:cNvSpPr txBox="1"/>
           <p:nvPr/>
         </p:nvSpPr>
@@ -9605,7 +9672,7 @@
       </p:sp>
       <p:sp>
         <p:nvSpPr>
-          <p:cNvPr id="8" name="Text 64"/>
+          <p:cNvPr id="8" name="Text 65"/>
           <p:cNvSpPr txBox="1"/>
           <p:nvPr/>
         </p:nvSpPr>
@@ -9647,7 +9714,7 @@
       </p:sp>
       <p:sp>
         <p:nvSpPr>
-          <p:cNvPr id="9" name="Text 65"/>
+          <p:cNvPr id="9" name="Text 66"/>
           <p:cNvSpPr txBox="1"/>
           <p:nvPr/>
         </p:nvSpPr>
@@ -9689,7 +9756,7 @@
       </p:sp>
       <p:sp>
         <p:nvSpPr>
-          <p:cNvPr id="10" name="Text 66"/>
+          <p:cNvPr id="10" name="Text 67"/>
           <p:cNvSpPr txBox="1"/>
           <p:nvPr/>
         </p:nvSpPr>
@@ -9917,7 +9984,7 @@
       </p:sp>
       <p:sp>
         <p:nvSpPr>
-          <p:cNvPr id="4" name="Text 67"/>
+          <p:cNvPr id="4" name="Text 68"/>
           <p:cNvSpPr txBox="1"/>
           <p:nvPr/>
         </p:nvSpPr>
@@ -9959,7 +10026,7 @@
       </p:sp>
       <p:sp>
         <p:nvSpPr>
-          <p:cNvPr id="5" name="Text 68"/>
+          <p:cNvPr id="5" name="Text 69"/>
           <p:cNvSpPr txBox="1"/>
           <p:nvPr/>
         </p:nvSpPr>
@@ -10028,7 +10095,7 @@
       </p:sp>
       <p:sp>
         <p:nvSpPr>
-          <p:cNvPr id="7" name="Text 69"/>
+          <p:cNvPr id="7" name="Text 70"/>
           <p:cNvSpPr txBox="1"/>
           <p:nvPr/>
         </p:nvSpPr>
@@ -10070,7 +10137,7 @@
       </p:sp>
       <p:sp>
         <p:nvSpPr>
-          <p:cNvPr id="8" name="Text 70"/>
+          <p:cNvPr id="8" name="Text 71"/>
           <p:cNvSpPr txBox="1"/>
           <p:nvPr/>
         </p:nvSpPr>
@@ -10112,7 +10179,7 @@
       </p:sp>
       <p:sp>
         <p:nvSpPr>
-          <p:cNvPr id="9" name="Text 71"/>
+          <p:cNvPr id="9" name="Text 72"/>
           <p:cNvSpPr txBox="1"/>
           <p:nvPr/>
         </p:nvSpPr>
@@ -10177,7 +10244,7 @@
       </p:sp>
       <p:sp>
         <p:nvSpPr>
-          <p:cNvPr id="11" name="Text 72"/>
+          <p:cNvPr id="11" name="Text 73"/>
           <p:cNvSpPr txBox="1"/>
           <p:nvPr/>
         </p:nvSpPr>
@@ -10219,7 +10286,7 @@
       </p:sp>
       <p:sp>
         <p:nvSpPr>
-          <p:cNvPr id="12" name="Text 73"/>
+          <p:cNvPr id="12" name="Text 74"/>
           <p:cNvSpPr txBox="1"/>
           <p:nvPr/>
         </p:nvSpPr>
@@ -10284,7 +10351,7 @@
       </p:sp>
       <p:sp>
         <p:nvSpPr>
-          <p:cNvPr id="14" name="Text 74"/>
+          <p:cNvPr id="14" name="Text 75"/>
           <p:cNvSpPr txBox="1"/>
           <p:nvPr/>
         </p:nvSpPr>
@@ -10326,7 +10393,7 @@
       </p:sp>
       <p:sp>
         <p:nvSpPr>
-          <p:cNvPr id="15" name="Text 75"/>
+          <p:cNvPr id="15" name="Text 76"/>
           <p:cNvSpPr txBox="1"/>
           <p:nvPr/>
         </p:nvSpPr>
@@ -10391,7 +10458,7 @@
       </p:sp>
       <p:sp>
         <p:nvSpPr>
-          <p:cNvPr id="17" name="Text 76"/>
+          <p:cNvPr id="17" name="Text 77"/>
           <p:cNvSpPr txBox="1"/>
           <p:nvPr/>
         </p:nvSpPr>
@@ -10433,7 +10500,7 @@
       </p:sp>
       <p:sp>
         <p:nvSpPr>
-          <p:cNvPr id="18" name="Text 77"/>
+          <p:cNvPr id="18" name="Text 78"/>
           <p:cNvSpPr txBox="1"/>
           <p:nvPr/>
         </p:nvSpPr>
@@ -10572,7 +10639,7 @@
       </p:pic>
       <p:sp>
         <p:nvSpPr>
-          <p:cNvPr id="3" name="Text 78"/>
+          <p:cNvPr id="3" name="Text 79"/>
           <p:cNvSpPr txBox="1"/>
           <p:nvPr/>
         </p:nvSpPr>

</xml_diff>

<commit_message>
Spectacular cover with blue hero panel
Co-Authored-By: Claude Opus 5.5 <noreply@anthropic.com>
Claude-Session: https://claude.ai/code/session_013jPvFVKNtfNrx98C7yQEsV
</commit_message>
<xml_diff>
--- a/deliverables/InboxAlly_Sales_Call_Deck.pptx
+++ b/deliverables/InboxAlly_Sales_Call_Deck.pptx
@@ -118,7 +118,7 @@
   <p:extLst>
     <p:ext uri="{521415D9-36F7-43E2-AB2F-B90AF26B5E84}">
       <p14:sectionLst xmlns:p14="http://schemas.microsoft.com/office/powerpoint/2010/main">
-        <p14:section name="Sales call" id="{aea5b775-273e-ced6-67f2-7e88f7809fc3}">
+        <p14:section name="Sales call" id="{4835998d-6f83-577e-ce62-90599d83a9a6}">
           <p14:sldIdLst>
             <p14:sldId id="256"/>
             <p14:sldId id="257"/>
@@ -126,7 +126,7 @@
             <p14:sldId id="259"/>
           </p14:sldIdLst>
         </p14:section>
-        <p14:section name="Template layouts" id="{04e9aab8-843c-7b17-73f6-932a3ebb7d4e}">
+        <p14:section name="Template layouts" id="{dc53e66b-15dd-7bda-055c-672f92d6326a}">
           <p14:sldIdLst>
             <p14:sldId id="260"/>
             <p14:sldId id="261"/>
@@ -136,7 +136,7 @@
             <p14:sldId id="265"/>
           </p14:sldIdLst>
         </p14:section>
-        <p14:section name="Close" id="{9f83ba1e-f66e-5786-95ce-3a68cd8378f1}">
+        <p14:section name="Close" id="{203fe8d7-9115-326b-1eee-daa9d0bb1c3a}">
           <p14:sldIdLst>
             <p14:sldId id="266"/>
             <p14:sldId id="267"/>
@@ -3512,8 +3512,8 @@
         </p:nvSpPr>
         <p:spPr>
           <a:xfrm>
-            <a:off x="7569200" y="787400"/>
-            <a:ext cx="3810000" cy="215900"/>
+            <a:off x="7874000" y="787400"/>
+            <a:ext cx="3505200" cy="215900"/>
           </a:xfrm>
           <a:prstGeom prst="rect">
             <a:avLst/>
@@ -3534,7 +3534,7 @@
             <a:r>
               <a:rPr lang="en-US" sz="1200" b="1" spc="100" kern="0" dirty="0">
                 <a:solidFill>
-                  <a:srgbClr val="0063FF"/>
+                  <a:srgbClr val="FFFFFF"/>
                 </a:solidFill>
                 <a:latin typeface="Arial" pitchFamily="34" charset="0"/>
                 <a:ea typeface="Arial" pitchFamily="34" charset="-122"/>
@@ -3554,8 +3554,8 @@
         </p:nvSpPr>
         <p:spPr>
           <a:xfrm>
-            <a:off x="7569200" y="1028700"/>
-            <a:ext cx="3810000" cy="254000"/>
+            <a:off x="7874000" y="1028700"/>
+            <a:ext cx="3505200" cy="254000"/>
           </a:xfrm>
           <a:prstGeom prst="rect">
             <a:avLst/>
@@ -3576,7 +3576,7 @@
             <a:r>
               <a:rPr lang="en-US" sz="1400" dirty="0">
                 <a:solidFill>
-                  <a:srgbClr val="3D4451"/>
+                  <a:srgbClr val="DDEFFF"/>
                 </a:solidFill>
                 <a:latin typeface="Arial" pitchFamily="34" charset="0"/>
                 <a:ea typeface="Arial" pitchFamily="34" charset="-122"/>
@@ -3596,7 +3596,7 @@
         </p:nvSpPr>
         <p:spPr>
           <a:xfrm>
-            <a:off x="812800" y="2260600"/>
+            <a:off x="812800" y="2159000"/>
             <a:ext cx="5080000" cy="215900"/>
           </a:xfrm>
           <a:prstGeom prst="rect">
@@ -3638,7 +3638,7 @@
         </p:nvSpPr>
         <p:spPr>
           <a:xfrm>
-            <a:off x="812800" y="2501900"/>
+            <a:off x="812800" y="2400300"/>
             <a:ext cx="6350000" cy="952500"/>
           </a:xfrm>
           <a:prstGeom prst="rect">
@@ -3680,22 +3680,22 @@
         </p:nvSpPr>
         <p:spPr>
           <a:xfrm>
-            <a:off x="812800" y="3556000"/>
-            <a:ext cx="8255000" cy="406400"/>
-          </a:xfrm>
-          <a:prstGeom prst="rect">
-            <a:avLst/>
-          </a:prstGeom>
-          <a:noFill/>
-          <a:ln/>
-        </p:spPr>
-        <p:txBody>
-          <a:bodyPr wrap="square" lIns="0" tIns="0" rIns="0" bIns="0" rtlCol="0" anchor="t"/>
-          <a:lstStyle/>
-          <a:p>
-            <a:pPr algn="l" indent="0" marL="0">
-              <a:lnSpc>
-                <a:spcPct val="115000"/>
+            <a:off x="812800" y="3454400"/>
+            <a:ext cx="6350000" cy="825500"/>
+          </a:xfrm>
+          <a:prstGeom prst="rect">
+            <a:avLst/>
+          </a:prstGeom>
+          <a:noFill/>
+          <a:ln/>
+        </p:spPr>
+        <p:txBody>
+          <a:bodyPr wrap="square" lIns="0" tIns="0" rIns="0" bIns="0" rtlCol="0" anchor="t"/>
+          <a:lstStyle/>
+          <a:p>
+            <a:pPr algn="l" indent="0" marL="0">
+              <a:lnSpc>
+                <a:spcPct val="110000"/>
               </a:lnSpc>
               <a:buNone/>
             </a:pPr>
@@ -3708,7 +3708,27 @@
                 <a:ea typeface="Georgia" pitchFamily="34" charset="-122"/>
                 <a:cs typeface="Georgia" pitchFamily="34" charset="-120"/>
               </a:rPr>
-              <a:t>Better inbox results. Zero platform changes.</a:t>
+              <a:t>Better inbox results.</a:t>
+            </a:r>
+            <a:endParaRPr lang="en-US" sz="2400" dirty="0"/>
+          </a:p>
+          <a:p>
+            <a:pPr algn="l" indent="0" marL="0">
+              <a:lnSpc>
+                <a:spcPct val="110000"/>
+              </a:lnSpc>
+              <a:buNone/>
+            </a:pPr>
+            <a:r>
+              <a:rPr lang="en-US" sz="2400" dirty="0">
+                <a:solidFill>
+                  <a:srgbClr val="0063FF"/>
+                </a:solidFill>
+                <a:latin typeface="Georgia" pitchFamily="34" charset="0"/>
+                <a:ea typeface="Georgia" pitchFamily="34" charset="-122"/>
+                <a:cs typeface="Georgia" pitchFamily="34" charset="-120"/>
+              </a:rPr>
+              <a:t>Zero platform changes.</a:t>
             </a:r>
             <a:endParaRPr lang="en-US" sz="2400" dirty="0"/>
           </a:p>

</xml_diff>

<commit_message>
Remove Over to you banner from slide 2
Co-Authored-By: Claude Opus 5.5 <noreply@anthropic.com>
Claude-Session: https://claude.ai/code/session_013jPvFVKNtfNrx98C7yQEsV
</commit_message>
<xml_diff>
--- a/deliverables/InboxAlly_Sales_Call_Deck.pptx
+++ b/deliverables/InboxAlly_Sales_Call_Deck.pptx
@@ -118,7 +118,7 @@
   <p:extLst>
     <p:ext uri="{521415D9-36F7-43E2-AB2F-B90AF26B5E84}">
       <p14:sectionLst xmlns:p14="http://schemas.microsoft.com/office/powerpoint/2010/main">
-        <p14:section name="Sales call" id="{4835998d-6f83-577e-ce62-90599d83a9a6}">
+        <p14:section name="Sales call" id="{c25827ab-f78b-aaa8-017e-99392a2c7377}">
           <p14:sldIdLst>
             <p14:sldId id="256"/>
             <p14:sldId id="257"/>
@@ -126,7 +126,7 @@
             <p14:sldId id="259"/>
           </p14:sldIdLst>
         </p14:section>
-        <p14:section name="Template layouts" id="{dc53e66b-15dd-7bda-055c-672f92d6326a}">
+        <p14:section name="Template layouts" id="{b5523fc8-13b4-07bd-6de5-8c342bb8f6f9}">
           <p14:sldIdLst>
             <p14:sldId id="260"/>
             <p14:sldId id="261"/>
@@ -136,7 +136,7 @@
             <p14:sldId id="265"/>
           </p14:sldIdLst>
         </p14:section>
-        <p14:section name="Close" id="{203fe8d7-9115-326b-1eee-daa9d0bb1c3a}">
+        <p14:section name="Close" id="{4196506d-f05d-f6ac-42a4-bde82357f5d3}">
           <p14:sldIdLst>
             <p14:sldId id="266"/>
             <p14:sldId id="267"/>
@@ -4127,7 +4127,7 @@
       </p:sp>
       <p:sp>
         <p:nvSpPr>
-          <p:cNvPr id="5" name="Text 80"/>
+          <p:cNvPr id="5" name="Text 77"/>
           <p:cNvSpPr txBox="1"/>
           <p:nvPr/>
         </p:nvSpPr>
@@ -4169,7 +4169,7 @@
       </p:sp>
       <p:sp>
         <p:nvSpPr>
-          <p:cNvPr id="6" name="Text 81"/>
+          <p:cNvPr id="6" name="Text 78"/>
           <p:cNvSpPr txBox="1"/>
           <p:nvPr/>
         </p:nvSpPr>
@@ -4276,7 +4276,7 @@
       </p:sp>
       <p:sp>
         <p:nvSpPr>
-          <p:cNvPr id="9" name="Text 82"/>
+          <p:cNvPr id="9" name="Text 79"/>
           <p:cNvSpPr txBox="1"/>
           <p:nvPr/>
         </p:nvSpPr>
@@ -4318,7 +4318,7 @@
       </p:sp>
       <p:sp>
         <p:nvSpPr>
-          <p:cNvPr id="10" name="Text 83"/>
+          <p:cNvPr id="10" name="Text 80"/>
           <p:cNvSpPr txBox="1"/>
           <p:nvPr/>
         </p:nvSpPr>
@@ -4425,7 +4425,7 @@
       </p:sp>
       <p:sp>
         <p:nvSpPr>
-          <p:cNvPr id="13" name="Text 84"/>
+          <p:cNvPr id="13" name="Text 81"/>
           <p:cNvSpPr txBox="1"/>
           <p:nvPr/>
         </p:nvSpPr>
@@ -4467,7 +4467,7 @@
       </p:sp>
       <p:sp>
         <p:nvSpPr>
-          <p:cNvPr id="14" name="Text 85"/>
+          <p:cNvPr id="14" name="Text 82"/>
           <p:cNvSpPr txBox="1"/>
           <p:nvPr/>
         </p:nvSpPr>
@@ -4574,7 +4574,7 @@
       </p:sp>
       <p:sp>
         <p:nvSpPr>
-          <p:cNvPr id="17" name="Text 86"/>
+          <p:cNvPr id="17" name="Text 83"/>
           <p:cNvSpPr txBox="1"/>
           <p:nvPr/>
         </p:nvSpPr>
@@ -4616,7 +4616,7 @@
       </p:sp>
       <p:sp>
         <p:nvSpPr>
-          <p:cNvPr id="18" name="Text 87"/>
+          <p:cNvPr id="18" name="Text 84"/>
           <p:cNvSpPr txBox="1"/>
           <p:nvPr/>
         </p:nvSpPr>
@@ -4658,7 +4658,7 @@
       </p:sp>
       <p:sp>
         <p:nvSpPr>
-          <p:cNvPr id="19" name="Text 88"/>
+          <p:cNvPr id="19" name="Text 85"/>
           <p:cNvSpPr txBox="1"/>
           <p:nvPr/>
         </p:nvSpPr>
@@ -4797,7 +4797,7 @@
       </p:pic>
       <p:sp>
         <p:nvSpPr>
-          <p:cNvPr id="3" name="Text 89"/>
+          <p:cNvPr id="3" name="Text 86"/>
           <p:cNvSpPr txBox="1"/>
           <p:nvPr/>
         </p:nvSpPr>
@@ -4839,7 +4839,7 @@
       </p:sp>
       <p:sp>
         <p:nvSpPr>
-          <p:cNvPr id="4" name="Text 90"/>
+          <p:cNvPr id="4" name="Text 87"/>
           <p:cNvSpPr txBox="1"/>
           <p:nvPr/>
         </p:nvSpPr>
@@ -5016,7 +5016,7 @@
       </p:sp>
       <p:sp>
         <p:nvSpPr>
-          <p:cNvPr id="5" name="Text 91"/>
+          <p:cNvPr id="5" name="Text 88"/>
           <p:cNvSpPr txBox="1"/>
           <p:nvPr/>
         </p:nvSpPr>
@@ -5058,7 +5058,7 @@
       </p:sp>
       <p:sp>
         <p:nvSpPr>
-          <p:cNvPr id="6" name="Text 92"/>
+          <p:cNvPr id="6" name="Text 89"/>
           <p:cNvSpPr txBox="1"/>
           <p:nvPr/>
         </p:nvSpPr>
@@ -5100,7 +5100,7 @@
       </p:sp>
       <p:sp>
         <p:nvSpPr>
-          <p:cNvPr id="7" name="Text 93"/>
+          <p:cNvPr id="7" name="Text 90"/>
           <p:cNvSpPr txBox="1"/>
           <p:nvPr/>
         </p:nvSpPr>
@@ -5169,7 +5169,7 @@
       </p:sp>
       <p:sp>
         <p:nvSpPr>
-          <p:cNvPr id="9" name="Text 94"/>
+          <p:cNvPr id="9" name="Text 91"/>
           <p:cNvSpPr txBox="1"/>
           <p:nvPr/>
         </p:nvSpPr>
@@ -5211,7 +5211,7 @@
       </p:sp>
       <p:sp>
         <p:nvSpPr>
-          <p:cNvPr id="10" name="Text 95"/>
+          <p:cNvPr id="10" name="Text 92"/>
           <p:cNvSpPr txBox="1"/>
           <p:nvPr/>
         </p:nvSpPr>
@@ -5253,7 +5253,7 @@
       </p:sp>
       <p:sp>
         <p:nvSpPr>
-          <p:cNvPr id="11" name="Text 96"/>
+          <p:cNvPr id="11" name="Text 93"/>
           <p:cNvSpPr txBox="1"/>
           <p:nvPr/>
         </p:nvSpPr>
@@ -5322,7 +5322,7 @@
       </p:sp>
       <p:sp>
         <p:nvSpPr>
-          <p:cNvPr id="13" name="Text 97"/>
+          <p:cNvPr id="13" name="Text 94"/>
           <p:cNvSpPr txBox="1"/>
           <p:nvPr/>
         </p:nvSpPr>
@@ -5364,7 +5364,7 @@
       </p:sp>
       <p:sp>
         <p:nvSpPr>
-          <p:cNvPr id="14" name="Text 98"/>
+          <p:cNvPr id="14" name="Text 95"/>
           <p:cNvSpPr txBox="1"/>
           <p:nvPr/>
         </p:nvSpPr>
@@ -5406,7 +5406,7 @@
       </p:sp>
       <p:sp>
         <p:nvSpPr>
-          <p:cNvPr id="15" name="Text 99"/>
+          <p:cNvPr id="15" name="Text 96"/>
           <p:cNvSpPr txBox="1"/>
           <p:nvPr/>
         </p:nvSpPr>
@@ -5475,7 +5475,7 @@
       </p:sp>
       <p:sp>
         <p:nvSpPr>
-          <p:cNvPr id="17" name="Text 100"/>
+          <p:cNvPr id="17" name="Text 97"/>
           <p:cNvSpPr txBox="1"/>
           <p:nvPr/>
         </p:nvSpPr>
@@ -5541,7 +5541,7 @@
       </p:pic>
       <p:sp>
         <p:nvSpPr>
-          <p:cNvPr id="19" name="Text 101"/>
+          <p:cNvPr id="19" name="Text 98"/>
           <p:cNvSpPr txBox="1"/>
           <p:nvPr/>
         </p:nvSpPr>
@@ -5583,7 +5583,7 @@
       </p:sp>
       <p:sp>
         <p:nvSpPr>
-          <p:cNvPr id="20" name="Text 102"/>
+          <p:cNvPr id="20" name="Text 99"/>
           <p:cNvSpPr txBox="1"/>
           <p:nvPr/>
         </p:nvSpPr>
@@ -5625,7 +5625,7 @@
       </p:sp>
       <p:sp>
         <p:nvSpPr>
-          <p:cNvPr id="21" name="Text 103"/>
+          <p:cNvPr id="21" name="Text 100"/>
           <p:cNvSpPr txBox="1"/>
           <p:nvPr/>
         </p:nvSpPr>
@@ -5714,7 +5714,7 @@
       </p:pic>
       <p:sp>
         <p:nvSpPr>
-          <p:cNvPr id="24" name="Text 104"/>
+          <p:cNvPr id="24" name="Text 101"/>
           <p:cNvSpPr txBox="1"/>
           <p:nvPr/>
         </p:nvSpPr>
@@ -5756,7 +5756,7 @@
       </p:sp>
       <p:sp>
         <p:nvSpPr>
-          <p:cNvPr id="25" name="Text 105"/>
+          <p:cNvPr id="25" name="Text 102"/>
           <p:cNvSpPr txBox="1"/>
           <p:nvPr/>
         </p:nvSpPr>
@@ -5798,7 +5798,7 @@
       </p:sp>
       <p:sp>
         <p:nvSpPr>
-          <p:cNvPr id="26" name="Text 106"/>
+          <p:cNvPr id="26" name="Text 103"/>
           <p:cNvSpPr txBox="1"/>
           <p:nvPr/>
         </p:nvSpPr>
@@ -6353,159 +6353,6 @@
       </p:sp>
       <p:sp>
         <p:nvSpPr>
-          <p:cNvPr id="14" name="Over to you band"/>
-          <p:cNvSpPr/>
-          <p:nvPr/>
-        </p:nvSpPr>
-        <p:spPr>
-          <a:xfrm>
-            <a:off x="812800" y="4876800"/>
-            <a:ext cx="10566400" cy="1117600"/>
-          </a:xfrm>
-          <a:prstGeom prst="roundRect">
-            <a:avLst>
-              <a:gd name="adj" fmla="val 11364"/>
-            </a:avLst>
-          </a:prstGeom>
-          <a:solidFill>
-            <a:srgbClr val="0062FF"/>
-          </a:solidFill>
-          <a:ln w="12700">
-            <a:solidFill>
-              <a:srgbClr val="0062FF"/>
-            </a:solidFill>
-            <a:prstDash val="solid"/>
-          </a:ln>
-        </p:spPr>
-      </p:sp>
-      <p:sp>
-        <p:nvSpPr>
-          <p:cNvPr id="15" name="Text 15"/>
-          <p:cNvSpPr txBox="1"/>
-          <p:nvPr/>
-        </p:nvSpPr>
-        <p:spPr>
-          <a:xfrm>
-            <a:off x="1168400" y="4876800"/>
-            <a:ext cx="2159000" cy="1117600"/>
-          </a:xfrm>
-          <a:prstGeom prst="rect">
-            <a:avLst/>
-          </a:prstGeom>
-          <a:noFill/>
-          <a:ln/>
-        </p:spPr>
-        <p:txBody>
-          <a:bodyPr wrap="square" lIns="0" tIns="0" rIns="0" bIns="0" rtlCol="0" anchor="ctr"/>
-          <a:lstStyle/>
-          <a:p>
-            <a:pPr algn="l" indent="0" marL="0">
-              <a:lnSpc>
-                <a:spcPct val="115000"/>
-              </a:lnSpc>
-              <a:buNone/>
-            </a:pPr>
-            <a:r>
-              <a:rPr lang="en-US" sz="2200" dirty="0">
-                <a:solidFill>
-                  <a:srgbClr val="FFFFFF"/>
-                </a:solidFill>
-                <a:latin typeface="Georgia" pitchFamily="34" charset="0"/>
-                <a:ea typeface="Georgia" pitchFamily="34" charset="-122"/>
-                <a:cs typeface="Georgia" pitchFamily="34" charset="-120"/>
-              </a:rPr>
-              <a:t>Over to you</a:t>
-            </a:r>
-            <a:endParaRPr lang="en-US" sz="2200" dirty="0"/>
-          </a:p>
-        </p:txBody>
-      </p:sp>
-      <p:sp>
-        <p:nvSpPr>
-          <p:cNvPr id="16" name="Text 16"/>
-          <p:cNvSpPr txBox="1"/>
-          <p:nvPr/>
-        </p:nvSpPr>
-        <p:spPr>
-          <a:xfrm>
-            <a:off x="3683000" y="4876800"/>
-            <a:ext cx="3314700" cy="1117600"/>
-          </a:xfrm>
-          <a:prstGeom prst="rect">
-            <a:avLst/>
-          </a:prstGeom>
-          <a:noFill/>
-          <a:ln/>
-        </p:spPr>
-        <p:txBody>
-          <a:bodyPr wrap="square" lIns="0" tIns="0" rIns="0" bIns="0" rtlCol="0" anchor="ctr"/>
-          <a:lstStyle/>
-          <a:p>
-            <a:pPr algn="l" indent="0" marL="0">
-              <a:lnSpc>
-                <a:spcPct val="130000"/>
-              </a:lnSpc>
-              <a:buNone/>
-            </a:pPr>
-            <a:r>
-              <a:rPr lang="en-US" sz="1400" dirty="0">
-                <a:solidFill>
-                  <a:srgbClr val="FFFFFF"/>
-                </a:solidFill>
-                <a:latin typeface="Arial" pitchFamily="34" charset="0"/>
-                <a:ea typeface="Arial" pitchFamily="34" charset="-122"/>
-                <a:cs typeface="Arial" pitchFamily="34" charset="-120"/>
-              </a:rPr>
-              <a:t>Share a bit about yourselves and your team.</a:t>
-            </a:r>
-            <a:endParaRPr lang="en-US" sz="1400" dirty="0"/>
-          </a:p>
-        </p:txBody>
-      </p:sp>
-      <p:sp>
-        <p:nvSpPr>
-          <p:cNvPr id="17" name="Text 17"/>
-          <p:cNvSpPr txBox="1"/>
-          <p:nvPr/>
-        </p:nvSpPr>
-        <p:spPr>
-          <a:xfrm>
-            <a:off x="7353300" y="4876800"/>
-            <a:ext cx="3683000" cy="1117600"/>
-          </a:xfrm>
-          <a:prstGeom prst="rect">
-            <a:avLst/>
-          </a:prstGeom>
-          <a:noFill/>
-          <a:ln/>
-        </p:spPr>
-        <p:txBody>
-          <a:bodyPr wrap="square" lIns="0" tIns="0" rIns="0" bIns="0" rtlCol="0" anchor="ctr"/>
-          <a:lstStyle/>
-          <a:p>
-            <a:pPr algn="l" indent="0" marL="0">
-              <a:lnSpc>
-                <a:spcPct val="130000"/>
-              </a:lnSpc>
-              <a:buNone/>
-            </a:pPr>
-            <a:r>
-              <a:rPr lang="en-US" sz="1400" dirty="0">
-                <a:solidFill>
-                  <a:srgbClr val="FFFFFF"/>
-                </a:solidFill>
-                <a:latin typeface="Arial" pitchFamily="34" charset="0"/>
-                <a:ea typeface="Arial" pitchFamily="34" charset="-122"/>
-                <a:cs typeface="Arial" pitchFamily="34" charset="-120"/>
-              </a:rPr>
-              <a:t>Outline the current deliverability issues you are running into right now.</a:t>
-            </a:r>
-            <a:endParaRPr lang="en-US" sz="1400" dirty="0"/>
-          </a:p>
-        </p:txBody>
-      </p:sp>
-      <p:sp>
-        <p:nvSpPr>
           <p:cNvPr id="25" name="Slide Number Placeholder 0"/>
           <p:cNvSpPr>
             <a:spLocks noGrp="1"/>
@@ -6669,7 +6516,7 @@
       </p:sp>
       <p:sp>
         <p:nvSpPr>
-          <p:cNvPr id="5" name="Text 18"/>
+          <p:cNvPr id="5" name="Text 15"/>
           <p:cNvSpPr txBox="1"/>
           <p:nvPr/>
         </p:nvSpPr>
@@ -6736,7 +6583,7 @@
       </p:sp>
       <p:sp>
         <p:nvSpPr>
-          <p:cNvPr id="7" name="Text 19"/>
+          <p:cNvPr id="7" name="Text 16"/>
           <p:cNvSpPr txBox="1"/>
           <p:nvPr/>
         </p:nvSpPr>
@@ -6803,7 +6650,7 @@
       </p:sp>
       <p:sp>
         <p:nvSpPr>
-          <p:cNvPr id="9" name="Text 20"/>
+          <p:cNvPr id="9" name="Text 17"/>
           <p:cNvSpPr txBox="1"/>
           <p:nvPr/>
         </p:nvSpPr>
@@ -6870,7 +6717,7 @@
       </p:sp>
       <p:sp>
         <p:nvSpPr>
-          <p:cNvPr id="11" name="Text 21"/>
+          <p:cNvPr id="11" name="Text 18"/>
           <p:cNvSpPr txBox="1"/>
           <p:nvPr/>
         </p:nvSpPr>
@@ -6937,7 +6784,7 @@
       </p:sp>
       <p:sp>
         <p:nvSpPr>
-          <p:cNvPr id="13" name="Text 22"/>
+          <p:cNvPr id="13" name="Text 19"/>
           <p:cNvSpPr txBox="1"/>
           <p:nvPr/>
         </p:nvSpPr>
@@ -6979,7 +6826,7 @@
       </p:sp>
       <p:sp>
         <p:nvSpPr>
-          <p:cNvPr id="14" name="Text 23"/>
+          <p:cNvPr id="14" name="Text 20"/>
           <p:cNvSpPr txBox="1"/>
           <p:nvPr/>
         </p:nvSpPr>
@@ -7021,7 +6868,7 @@
       </p:sp>
       <p:sp>
         <p:nvSpPr>
-          <p:cNvPr id="15" name="Text 24"/>
+          <p:cNvPr id="15" name="Text 21"/>
           <p:cNvSpPr txBox="1"/>
           <p:nvPr/>
         </p:nvSpPr>
@@ -7063,7 +6910,7 @@
       </p:sp>
       <p:sp>
         <p:nvSpPr>
-          <p:cNvPr id="16" name="Text 25"/>
+          <p:cNvPr id="16" name="Text 22"/>
           <p:cNvSpPr txBox="1"/>
           <p:nvPr/>
         </p:nvSpPr>
@@ -7105,7 +6952,7 @@
       </p:sp>
       <p:sp>
         <p:nvSpPr>
-          <p:cNvPr id="17" name="Text 26"/>
+          <p:cNvPr id="17" name="Text 23"/>
           <p:cNvSpPr txBox="1"/>
           <p:nvPr/>
         </p:nvSpPr>
@@ -7147,7 +6994,7 @@
       </p:sp>
       <p:sp>
         <p:nvSpPr>
-          <p:cNvPr id="18" name="Text 27"/>
+          <p:cNvPr id="18" name="Text 24"/>
           <p:cNvSpPr txBox="1"/>
           <p:nvPr/>
         </p:nvSpPr>
@@ -7189,7 +7036,7 @@
       </p:sp>
       <p:sp>
         <p:nvSpPr>
-          <p:cNvPr id="19" name="Text 28"/>
+          <p:cNvPr id="19" name="Text 25"/>
           <p:cNvSpPr txBox="1"/>
           <p:nvPr/>
         </p:nvSpPr>
@@ -7231,7 +7078,7 @@
       </p:sp>
       <p:sp>
         <p:nvSpPr>
-          <p:cNvPr id="20" name="Text 29"/>
+          <p:cNvPr id="20" name="Text 26"/>
           <p:cNvSpPr txBox="1"/>
           <p:nvPr/>
         </p:nvSpPr>
@@ -7273,7 +7120,7 @@
       </p:sp>
       <p:sp>
         <p:nvSpPr>
-          <p:cNvPr id="21" name="Text 30"/>
+          <p:cNvPr id="21" name="Text 27"/>
           <p:cNvSpPr txBox="1"/>
           <p:nvPr/>
         </p:nvSpPr>
@@ -7315,7 +7162,7 @@
       </p:sp>
       <p:sp>
         <p:nvSpPr>
-          <p:cNvPr id="22" name="Text 31"/>
+          <p:cNvPr id="22" name="Text 28"/>
           <p:cNvSpPr txBox="1"/>
           <p:nvPr/>
         </p:nvSpPr>
@@ -7357,7 +7204,7 @@
       </p:sp>
       <p:sp>
         <p:nvSpPr>
-          <p:cNvPr id="23" name="Text 32"/>
+          <p:cNvPr id="23" name="Text 29"/>
           <p:cNvSpPr txBox="1"/>
           <p:nvPr/>
         </p:nvSpPr>
@@ -7399,7 +7246,7 @@
       </p:sp>
       <p:sp>
         <p:nvSpPr>
-          <p:cNvPr id="24" name="Text 33"/>
+          <p:cNvPr id="24" name="Text 30"/>
           <p:cNvSpPr txBox="1"/>
           <p:nvPr/>
         </p:nvSpPr>
@@ -7441,7 +7288,7 @@
       </p:sp>
       <p:sp>
         <p:nvSpPr>
-          <p:cNvPr id="25" name="Text 34"/>
+          <p:cNvPr id="25" name="Text 31"/>
           <p:cNvSpPr txBox="1"/>
           <p:nvPr/>
         </p:nvSpPr>
@@ -7483,7 +7330,7 @@
       </p:sp>
       <p:sp>
         <p:nvSpPr>
-          <p:cNvPr id="26" name="Text 35"/>
+          <p:cNvPr id="26" name="Text 32"/>
           <p:cNvSpPr txBox="1"/>
           <p:nvPr/>
         </p:nvSpPr>
@@ -7525,7 +7372,7 @@
       </p:sp>
       <p:sp>
         <p:nvSpPr>
-          <p:cNvPr id="27" name="Text 36"/>
+          <p:cNvPr id="27" name="Text 33"/>
           <p:cNvSpPr txBox="1"/>
           <p:nvPr/>
         </p:nvSpPr>
@@ -7567,7 +7414,7 @@
       </p:sp>
       <p:sp>
         <p:nvSpPr>
-          <p:cNvPr id="28" name="Text 37"/>
+          <p:cNvPr id="28" name="Text 34"/>
           <p:cNvSpPr txBox="1"/>
           <p:nvPr/>
         </p:nvSpPr>
@@ -7636,7 +7483,7 @@
       </p:sp>
       <p:sp>
         <p:nvSpPr>
-          <p:cNvPr id="30" name="Text 38"/>
+          <p:cNvPr id="30" name="Text 35"/>
           <p:cNvSpPr txBox="1"/>
           <p:nvPr/>
         </p:nvSpPr>
@@ -7678,7 +7525,7 @@
       </p:sp>
       <p:sp>
         <p:nvSpPr>
-          <p:cNvPr id="31" name="Text 39"/>
+          <p:cNvPr id="31" name="Text 36"/>
           <p:cNvSpPr txBox="1"/>
           <p:nvPr/>
         </p:nvSpPr>
@@ -7743,7 +7590,7 @@
       </p:sp>
       <p:sp>
         <p:nvSpPr>
-          <p:cNvPr id="33" name="Text 40"/>
+          <p:cNvPr id="33" name="Text 37"/>
           <p:cNvSpPr txBox="1"/>
           <p:nvPr/>
         </p:nvSpPr>
@@ -7808,7 +7655,7 @@
       </p:sp>
       <p:sp>
         <p:nvSpPr>
-          <p:cNvPr id="35" name="Text 41"/>
+          <p:cNvPr id="35" name="Text 38"/>
           <p:cNvSpPr txBox="1"/>
           <p:nvPr/>
         </p:nvSpPr>
@@ -7873,7 +7720,7 @@
       </p:sp>
       <p:sp>
         <p:nvSpPr>
-          <p:cNvPr id="37" name="Text 42"/>
+          <p:cNvPr id="37" name="Text 39"/>
           <p:cNvSpPr txBox="1"/>
           <p:nvPr/>
         </p:nvSpPr>
@@ -8115,7 +7962,7 @@
       </p:sp>
       <p:sp>
         <p:nvSpPr>
-          <p:cNvPr id="4" name="Text 43"/>
+          <p:cNvPr id="4" name="Text 40"/>
           <p:cNvSpPr txBox="1"/>
           <p:nvPr/>
         </p:nvSpPr>
@@ -8157,7 +8004,7 @@
       </p:sp>
       <p:sp>
         <p:nvSpPr>
-          <p:cNvPr id="5" name="Text 44"/>
+          <p:cNvPr id="5" name="Text 41"/>
           <p:cNvSpPr txBox="1"/>
           <p:nvPr/>
         </p:nvSpPr>
@@ -8226,7 +8073,7 @@
       </p:sp>
       <p:sp>
         <p:nvSpPr>
-          <p:cNvPr id="7" name="Text 45"/>
+          <p:cNvPr id="7" name="Text 42"/>
           <p:cNvSpPr txBox="1"/>
           <p:nvPr/>
         </p:nvSpPr>
@@ -8268,7 +8115,7 @@
       </p:sp>
       <p:sp>
         <p:nvSpPr>
-          <p:cNvPr id="8" name="Text 46"/>
+          <p:cNvPr id="8" name="Text 43"/>
           <p:cNvSpPr txBox="1"/>
           <p:nvPr/>
         </p:nvSpPr>
@@ -8337,7 +8184,7 @@
       </p:sp>
       <p:sp>
         <p:nvSpPr>
-          <p:cNvPr id="10" name="Text 47"/>
+          <p:cNvPr id="10" name="Text 44"/>
           <p:cNvSpPr txBox="1"/>
           <p:nvPr/>
         </p:nvSpPr>
@@ -8379,7 +8226,7 @@
       </p:sp>
       <p:sp>
         <p:nvSpPr>
-          <p:cNvPr id="11" name="Text 48"/>
+          <p:cNvPr id="11" name="Text 45"/>
           <p:cNvSpPr txBox="1"/>
           <p:nvPr/>
         </p:nvSpPr>
@@ -8448,7 +8295,7 @@
       </p:sp>
       <p:sp>
         <p:nvSpPr>
-          <p:cNvPr id="13" name="Text 49"/>
+          <p:cNvPr id="13" name="Text 46"/>
           <p:cNvSpPr txBox="1"/>
           <p:nvPr/>
         </p:nvSpPr>
@@ -8490,7 +8337,7 @@
       </p:sp>
       <p:sp>
         <p:nvSpPr>
-          <p:cNvPr id="14" name="Text 50"/>
+          <p:cNvPr id="14" name="Text 47"/>
           <p:cNvSpPr txBox="1"/>
           <p:nvPr/>
         </p:nvSpPr>
@@ -8532,7 +8379,7 @@
       </p:sp>
       <p:sp>
         <p:nvSpPr>
-          <p:cNvPr id="15" name="Text 51"/>
+          <p:cNvPr id="15" name="Text 48"/>
           <p:cNvSpPr txBox="1"/>
           <p:nvPr/>
         </p:nvSpPr>
@@ -8574,7 +8421,7 @@
       </p:sp>
       <p:sp>
         <p:nvSpPr>
-          <p:cNvPr id="16" name="Text 52"/>
+          <p:cNvPr id="16" name="Text 49"/>
           <p:cNvSpPr txBox="1"/>
           <p:nvPr/>
         </p:nvSpPr>
@@ -8616,7 +8463,7 @@
       </p:sp>
       <p:sp>
         <p:nvSpPr>
-          <p:cNvPr id="17" name="Text 53"/>
+          <p:cNvPr id="17" name="Text 50"/>
           <p:cNvSpPr txBox="1"/>
           <p:nvPr/>
         </p:nvSpPr>
@@ -8658,7 +8505,7 @@
       </p:sp>
       <p:sp>
         <p:nvSpPr>
-          <p:cNvPr id="18" name="Text 54"/>
+          <p:cNvPr id="18" name="Text 51"/>
           <p:cNvSpPr txBox="1"/>
           <p:nvPr/>
         </p:nvSpPr>
@@ -8700,7 +8547,7 @@
       </p:sp>
       <p:sp>
         <p:nvSpPr>
-          <p:cNvPr id="19" name="Text 55"/>
+          <p:cNvPr id="19" name="Text 52"/>
           <p:cNvSpPr txBox="1"/>
           <p:nvPr/>
         </p:nvSpPr>
@@ -8742,7 +8589,7 @@
       </p:sp>
       <p:sp>
         <p:nvSpPr>
-          <p:cNvPr id="20" name="Text 56"/>
+          <p:cNvPr id="20" name="Text 53"/>
           <p:cNvSpPr txBox="1"/>
           <p:nvPr/>
         </p:nvSpPr>
@@ -8784,7 +8631,7 @@
       </p:sp>
       <p:sp>
         <p:nvSpPr>
-          <p:cNvPr id="21" name="Text 57"/>
+          <p:cNvPr id="21" name="Text 54"/>
           <p:cNvSpPr txBox="1"/>
           <p:nvPr/>
         </p:nvSpPr>
@@ -8826,7 +8673,7 @@
       </p:sp>
       <p:sp>
         <p:nvSpPr>
-          <p:cNvPr id="22" name="Text 58"/>
+          <p:cNvPr id="22" name="Text 55"/>
           <p:cNvSpPr txBox="1"/>
           <p:nvPr/>
         </p:nvSpPr>
@@ -8868,7 +8715,7 @@
       </p:sp>
       <p:sp>
         <p:nvSpPr>
-          <p:cNvPr id="23" name="Text 59"/>
+          <p:cNvPr id="23" name="Text 56"/>
           <p:cNvSpPr txBox="1"/>
           <p:nvPr/>
         </p:nvSpPr>
@@ -8910,7 +8757,7 @@
       </p:sp>
       <p:sp>
         <p:nvSpPr>
-          <p:cNvPr id="24" name="Text 60"/>
+          <p:cNvPr id="24" name="Text 57"/>
           <p:cNvSpPr txBox="1"/>
           <p:nvPr/>
         </p:nvSpPr>
@@ -9524,7 +9371,7 @@
       </p:sp>
       <p:sp>
         <p:nvSpPr>
-          <p:cNvPr id="4" name="Text 61"/>
+          <p:cNvPr id="4" name="Text 58"/>
           <p:cNvSpPr txBox="1"/>
           <p:nvPr/>
         </p:nvSpPr>
@@ -9566,7 +9413,7 @@
       </p:sp>
       <p:sp>
         <p:nvSpPr>
-          <p:cNvPr id="5" name="Text 62"/>
+          <p:cNvPr id="5" name="Text 59"/>
           <p:cNvSpPr txBox="1"/>
           <p:nvPr/>
         </p:nvSpPr>
@@ -9608,7 +9455,7 @@
       </p:sp>
       <p:sp>
         <p:nvSpPr>
-          <p:cNvPr id="6" name="Text 63"/>
+          <p:cNvPr id="6" name="Text 60"/>
           <p:cNvSpPr txBox="1"/>
           <p:nvPr/>
         </p:nvSpPr>
@@ -9650,7 +9497,7 @@
       </p:sp>
       <p:sp>
         <p:nvSpPr>
-          <p:cNvPr id="7" name="Text 64"/>
+          <p:cNvPr id="7" name="Text 61"/>
           <p:cNvSpPr txBox="1"/>
           <p:nvPr/>
         </p:nvSpPr>
@@ -9692,7 +9539,7 @@
       </p:sp>
       <p:sp>
         <p:nvSpPr>
-          <p:cNvPr id="8" name="Text 65"/>
+          <p:cNvPr id="8" name="Text 62"/>
           <p:cNvSpPr txBox="1"/>
           <p:nvPr/>
         </p:nvSpPr>
@@ -9734,7 +9581,7 @@
       </p:sp>
       <p:sp>
         <p:nvSpPr>
-          <p:cNvPr id="9" name="Text 66"/>
+          <p:cNvPr id="9" name="Text 63"/>
           <p:cNvSpPr txBox="1"/>
           <p:nvPr/>
         </p:nvSpPr>
@@ -9776,7 +9623,7 @@
       </p:sp>
       <p:sp>
         <p:nvSpPr>
-          <p:cNvPr id="10" name="Text 67"/>
+          <p:cNvPr id="10" name="Text 64"/>
           <p:cNvSpPr txBox="1"/>
           <p:nvPr/>
         </p:nvSpPr>
@@ -10004,7 +9851,7 @@
       </p:sp>
       <p:sp>
         <p:nvSpPr>
-          <p:cNvPr id="4" name="Text 68"/>
+          <p:cNvPr id="4" name="Text 65"/>
           <p:cNvSpPr txBox="1"/>
           <p:nvPr/>
         </p:nvSpPr>
@@ -10046,7 +9893,7 @@
       </p:sp>
       <p:sp>
         <p:nvSpPr>
-          <p:cNvPr id="5" name="Text 69"/>
+          <p:cNvPr id="5" name="Text 66"/>
           <p:cNvSpPr txBox="1"/>
           <p:nvPr/>
         </p:nvSpPr>
@@ -10115,7 +9962,7 @@
       </p:sp>
       <p:sp>
         <p:nvSpPr>
-          <p:cNvPr id="7" name="Text 70"/>
+          <p:cNvPr id="7" name="Text 67"/>
           <p:cNvSpPr txBox="1"/>
           <p:nvPr/>
         </p:nvSpPr>
@@ -10157,7 +10004,7 @@
       </p:sp>
       <p:sp>
         <p:nvSpPr>
-          <p:cNvPr id="8" name="Text 71"/>
+          <p:cNvPr id="8" name="Text 68"/>
           <p:cNvSpPr txBox="1"/>
           <p:nvPr/>
         </p:nvSpPr>
@@ -10199,7 +10046,7 @@
       </p:sp>
       <p:sp>
         <p:nvSpPr>
-          <p:cNvPr id="9" name="Text 72"/>
+          <p:cNvPr id="9" name="Text 69"/>
           <p:cNvSpPr txBox="1"/>
           <p:nvPr/>
         </p:nvSpPr>
@@ -10264,7 +10111,7 @@
       </p:sp>
       <p:sp>
         <p:nvSpPr>
-          <p:cNvPr id="11" name="Text 73"/>
+          <p:cNvPr id="11" name="Text 70"/>
           <p:cNvSpPr txBox="1"/>
           <p:nvPr/>
         </p:nvSpPr>
@@ -10306,7 +10153,7 @@
       </p:sp>
       <p:sp>
         <p:nvSpPr>
-          <p:cNvPr id="12" name="Text 74"/>
+          <p:cNvPr id="12" name="Text 71"/>
           <p:cNvSpPr txBox="1"/>
           <p:nvPr/>
         </p:nvSpPr>
@@ -10371,7 +10218,7 @@
       </p:sp>
       <p:sp>
         <p:nvSpPr>
-          <p:cNvPr id="14" name="Text 75"/>
+          <p:cNvPr id="14" name="Text 72"/>
           <p:cNvSpPr txBox="1"/>
           <p:nvPr/>
         </p:nvSpPr>
@@ -10413,7 +10260,7 @@
       </p:sp>
       <p:sp>
         <p:nvSpPr>
-          <p:cNvPr id="15" name="Text 76"/>
+          <p:cNvPr id="15" name="Text 73"/>
           <p:cNvSpPr txBox="1"/>
           <p:nvPr/>
         </p:nvSpPr>
@@ -10478,7 +10325,7 @@
       </p:sp>
       <p:sp>
         <p:nvSpPr>
-          <p:cNvPr id="17" name="Text 77"/>
+          <p:cNvPr id="17" name="Text 74"/>
           <p:cNvSpPr txBox="1"/>
           <p:nvPr/>
         </p:nvSpPr>
@@ -10520,7 +10367,7 @@
       </p:sp>
       <p:sp>
         <p:nvSpPr>
-          <p:cNvPr id="18" name="Text 78"/>
+          <p:cNvPr id="18" name="Text 75"/>
           <p:cNvSpPr txBox="1"/>
           <p:nvPr/>
         </p:nvSpPr>
@@ -10659,7 +10506,7 @@
       </p:pic>
       <p:sp>
         <p:nvSpPr>
-          <p:cNvPr id="3" name="Text 79"/>
+          <p:cNvPr id="3" name="Text 76"/>
           <p:cNvSpPr txBox="1"/>
           <p:nvPr/>
         </p:nvSpPr>

</xml_diff>